<commit_message>
Refresh the screenshots and deck for the current UI
Adds the two moves pages, which the deck had no shots of.

Co-Authored-By: Claude Opus 5 <noreply@anthropic.com>
</commit_message>
<xml_diff>
--- a/docs/Pokemon-CRM-demo.pptx
+++ b/docs/Pokemon-CRM-demo.pptx
@@ -13,7 +13,12 @@
     <p:sldId id="261" r:id="rId7"/>
     <p:sldId id="262" r:id="rId8"/>
     <p:sldId id="263" r:id="rId9"/>
+    <p:sldId id="267" r:id="rId18"/>
+    <p:sldId id="268" r:id="rId19"/>
+    <p:sldId id="269" r:id="rId20"/>
+    <p:sldId id="270" r:id="rId21"/>
     <p:sldId id="264" r:id="rId10"/>
+    <p:sldId id="271" r:id="rId22"/>
     <p:sldId id="265" r:id="rId11"/>
     <p:sldId id="266" r:id="rId12"/>
   </p:sldIdLst>
@@ -712,6 +717,446 @@
             <a:fld id="{F7021451-1387-4CA6-816F-3879F97B5CBC}" type="slidenum">
               <a:rPr lang="en-US"/>
               <a:t>11</a:t>
+            </a:fld>
+            <a:endParaRPr lang="en-US"/>
+          </a:p>
+        </p:txBody>
+      </p:sp>
+    </p:spTree>
+    <p:extLst>
+      <p:ext uri="{BB962C8B-B14F-4D97-AF65-F5344CB8AC3E}">
+        <p14:creationId xmlns:p14="http://schemas.microsoft.com/office/powerpoint/2010/main" val="1024086991"/>
+      </p:ext>
+    </p:extLst>
+  </p:cSld>
+  <p:clrMapOvr>
+    <a:masterClrMapping/>
+  </p:clrMapOvr>
+</p:notes>
+</file>
+
+<file path=ppt/notesSlides/notesSlide12.xml><?xml version="1.0" encoding="utf-8"?>
+<p:notes xmlns:a="http://schemas.openxmlformats.org/drawingml/2006/main" xmlns:r="http://schemas.openxmlformats.org/officeDocument/2006/relationships" xmlns:p="http://schemas.openxmlformats.org/presentationml/2006/main">
+  <p:cSld>
+    <p:spTree>
+      <p:nvGrpSpPr>
+        <p:cNvPr id="1" name=""/>
+        <p:cNvGrpSpPr/>
+        <p:nvPr/>
+      </p:nvGrpSpPr>
+      <p:grpSpPr>
+        <a:xfrm>
+          <a:off x="0" y="0"/>
+          <a:ext cx="0" cy="0"/>
+          <a:chOff x="0" y="0"/>
+          <a:chExt cx="0" cy="0"/>
+        </a:xfrm>
+      </p:grpSpPr>
+      <p:sp>
+        <p:nvSpPr>
+          <p:cNvPr id="2" name="Slide Image Placeholder 1"/>
+          <p:cNvSpPr>
+            <a:spLocks noGrp="1" noRot="1" noChangeAspect="1"/>
+          </p:cNvSpPr>
+          <p:nvPr>
+            <p:ph type="sldImg"/>
+          </p:nvPr>
+        </p:nvSpPr>
+        <p:spPr/>
+      </p:sp>
+      <p:sp>
+        <p:nvSpPr>
+          <p:cNvPr id="3" name="Notes Placeholder 2"/>
+          <p:cNvSpPr>
+            <a:spLocks noGrp="1"/>
+          </p:cNvSpPr>
+          <p:nvPr>
+            <p:ph type="body" idx="1"/>
+          </p:nvPr>
+        </p:nvSpPr>
+        <p:spPr/>
+        <p:txBody>
+          <a:bodyPr/>
+          <a:lstStyle/>
+          <a:p>
+            <a:r>
+              <a:rPr lang="en-US" dirty="0"/>
+              <a:t>Moves are the course catalogue in the advising analogy — pokemon_moves is the enrolment record, one row per Pokémon, move and learn method.</a:t>
+            </a:r>
+            <a:endParaRPr lang="en-US" dirty="0"/>
+          </a:p>
+        </p:txBody>
+      </p:sp>
+      <p:sp>
+        <p:nvSpPr>
+          <p:cNvPr id="4" name="Slide Number Placeholder 3"/>
+          <p:cNvSpPr>
+            <a:spLocks noGrp="1"/>
+          </p:cNvSpPr>
+          <p:nvPr>
+            <p:ph type="sldNum" sz="quarter" idx="10"/>
+          </p:nvPr>
+        </p:nvSpPr>
+        <p:spPr/>
+        <p:txBody>
+          <a:bodyPr/>
+          <a:lstStyle/>
+          <a:p>
+            <a:fld id="{F7021451-1387-4CA6-816F-3879F97B5CBC}" type="slidenum">
+              <a:rPr lang="en-US"/>
+              <a:t>3</a:t>
+            </a:fld>
+            <a:endParaRPr lang="en-US"/>
+          </a:p>
+        </p:txBody>
+      </p:sp>
+    </p:spTree>
+    <p:extLst>
+      <p:ext uri="{BB962C8B-B14F-4D97-AF65-F5344CB8AC3E}">
+        <p14:creationId xmlns:p14="http://schemas.microsoft.com/office/powerpoint/2010/main" val="1024086991"/>
+      </p:ext>
+    </p:extLst>
+  </p:cSld>
+  <p:clrMapOvr>
+    <a:masterClrMapping/>
+  </p:clrMapOvr>
+</p:notes>
+</file>
+
+<file path=ppt/notesSlides/notesSlide13.xml><?xml version="1.0" encoding="utf-8"?>
+<p:notes xmlns:a="http://schemas.openxmlformats.org/drawingml/2006/main" xmlns:r="http://schemas.openxmlformats.org/officeDocument/2006/relationships" xmlns:p="http://schemas.openxmlformats.org/presentationml/2006/main">
+  <p:cSld>
+    <p:spTree>
+      <p:nvGrpSpPr>
+        <p:cNvPr id="1" name=""/>
+        <p:cNvGrpSpPr/>
+        <p:nvPr/>
+      </p:nvGrpSpPr>
+      <p:grpSpPr>
+        <a:xfrm>
+          <a:off x="0" y="0"/>
+          <a:ext cx="0" cy="0"/>
+          <a:chOff x="0" y="0"/>
+          <a:chExt cx="0" cy="0"/>
+        </a:xfrm>
+      </p:grpSpPr>
+      <p:sp>
+        <p:nvSpPr>
+          <p:cNvPr id="2" name="Slide Image Placeholder 1"/>
+          <p:cNvSpPr>
+            <a:spLocks noGrp="1" noRot="1" noChangeAspect="1"/>
+          </p:cNvSpPr>
+          <p:nvPr>
+            <p:ph type="sldImg"/>
+          </p:nvPr>
+        </p:nvSpPr>
+        <p:spPr/>
+      </p:sp>
+      <p:sp>
+        <p:nvSpPr>
+          <p:cNvPr id="3" name="Notes Placeholder 2"/>
+          <p:cNvSpPr>
+            <a:spLocks noGrp="1"/>
+          </p:cNvSpPr>
+          <p:nvPr>
+            <p:ph type="body" idx="1"/>
+          </p:nvPr>
+        </p:nvSpPr>
+        <p:spPr/>
+        <p:txBody>
+          <a:bodyPr/>
+          <a:lstStyle/>
+          <a:p>
+            <a:r>
+              <a:rPr lang="en-US" dirty="0"/>
+              <a:t>The learn-method breakdown is the part worth pausing on: it is the same join read three ways, and none of it is precomputed.</a:t>
+            </a:r>
+            <a:endParaRPr lang="en-US" dirty="0"/>
+          </a:p>
+        </p:txBody>
+      </p:sp>
+      <p:sp>
+        <p:nvSpPr>
+          <p:cNvPr id="4" name="Slide Number Placeholder 3"/>
+          <p:cNvSpPr>
+            <a:spLocks noGrp="1"/>
+          </p:cNvSpPr>
+          <p:nvPr>
+            <p:ph type="sldNum" sz="quarter" idx="10"/>
+          </p:nvPr>
+        </p:nvSpPr>
+        <p:spPr/>
+        <p:txBody>
+          <a:bodyPr/>
+          <a:lstStyle/>
+          <a:p>
+            <a:fld id="{F7021451-1387-4CA6-816F-3879F97B5CBC}" type="slidenum">
+              <a:rPr lang="en-US"/>
+              <a:t>3</a:t>
+            </a:fld>
+            <a:endParaRPr lang="en-US"/>
+          </a:p>
+        </p:txBody>
+      </p:sp>
+    </p:spTree>
+    <p:extLst>
+      <p:ext uri="{BB962C8B-B14F-4D97-AF65-F5344CB8AC3E}">
+        <p14:creationId xmlns:p14="http://schemas.microsoft.com/office/powerpoint/2010/main" val="1024086991"/>
+      </p:ext>
+    </p:extLst>
+  </p:cSld>
+  <p:clrMapOvr>
+    <a:masterClrMapping/>
+  </p:clrMapOvr>
+</p:notes>
+</file>
+
+<file path=ppt/notesSlides/notesSlide14.xml><?xml version="1.0" encoding="utf-8"?>
+<p:notes xmlns:a="http://schemas.openxmlformats.org/drawingml/2006/main" xmlns:r="http://schemas.openxmlformats.org/officeDocument/2006/relationships" xmlns:p="http://schemas.openxmlformats.org/presentationml/2006/main">
+  <p:cSld>
+    <p:spTree>
+      <p:nvGrpSpPr>
+        <p:cNvPr id="1" name=""/>
+        <p:cNvGrpSpPr/>
+        <p:nvPr/>
+      </p:nvGrpSpPr>
+      <p:grpSpPr>
+        <a:xfrm>
+          <a:off x="0" y="0"/>
+          <a:ext cx="0" cy="0"/>
+          <a:chOff x="0" y="0"/>
+          <a:chExt cx="0" cy="0"/>
+        </a:xfrm>
+      </p:grpSpPr>
+      <p:sp>
+        <p:nvSpPr>
+          <p:cNvPr id="2" name="Slide Image Placeholder 1"/>
+          <p:cNvSpPr>
+            <a:spLocks noGrp="1" noRot="1" noChangeAspect="1"/>
+          </p:cNvSpPr>
+          <p:nvPr>
+            <p:ph type="sldImg"/>
+          </p:nvPr>
+        </p:nvSpPr>
+        <p:spPr/>
+      </p:sp>
+      <p:sp>
+        <p:nvSpPr>
+          <p:cNvPr id="3" name="Notes Placeholder 2"/>
+          <p:cNvSpPr>
+            <a:spLocks noGrp="1"/>
+          </p:cNvSpPr>
+          <p:nvPr>
+            <p:ph type="body" idx="1"/>
+          </p:nvPr>
+        </p:nvSpPr>
+        <p:spPr/>
+        <p:txBody>
+          <a:bodyPr/>
+          <a:lstStyle/>
+          <a:p>
+            <a:r>
+              <a:rPr lang="en-US" dirty="0"/>
+              <a:t>Notes and flags are attributed to whoever the app is acting as. There is no auth behind it — the header is unverified, and the deck says so on the last slide.</a:t>
+            </a:r>
+            <a:endParaRPr lang="en-US" dirty="0"/>
+          </a:p>
+        </p:txBody>
+      </p:sp>
+      <p:sp>
+        <p:nvSpPr>
+          <p:cNvPr id="4" name="Slide Number Placeholder 3"/>
+          <p:cNvSpPr>
+            <a:spLocks noGrp="1"/>
+          </p:cNvSpPr>
+          <p:nvPr>
+            <p:ph type="sldNum" sz="quarter" idx="10"/>
+          </p:nvPr>
+        </p:nvSpPr>
+        <p:spPr/>
+        <p:txBody>
+          <a:bodyPr/>
+          <a:lstStyle/>
+          <a:p>
+            <a:fld id="{F7021451-1387-4CA6-816F-3879F97B5CBC}" type="slidenum">
+              <a:rPr lang="en-US"/>
+              <a:t>3</a:t>
+            </a:fld>
+            <a:endParaRPr lang="en-US"/>
+          </a:p>
+        </p:txBody>
+      </p:sp>
+    </p:spTree>
+    <p:extLst>
+      <p:ext uri="{BB962C8B-B14F-4D97-AF65-F5344CB8AC3E}">
+        <p14:creationId xmlns:p14="http://schemas.microsoft.com/office/powerpoint/2010/main" val="1024086991"/>
+      </p:ext>
+    </p:extLst>
+  </p:cSld>
+  <p:clrMapOvr>
+    <a:masterClrMapping/>
+  </p:clrMapOvr>
+</p:notes>
+</file>
+
+<file path=ppt/notesSlides/notesSlide15.xml><?xml version="1.0" encoding="utf-8"?>
+<p:notes xmlns:a="http://schemas.openxmlformats.org/drawingml/2006/main" xmlns:r="http://schemas.openxmlformats.org/officeDocument/2006/relationships" xmlns:p="http://schemas.openxmlformats.org/presentationml/2006/main">
+  <p:cSld>
+    <p:spTree>
+      <p:nvGrpSpPr>
+        <p:cNvPr id="1" name=""/>
+        <p:cNvGrpSpPr/>
+        <p:nvPr/>
+      </p:nvGrpSpPr>
+      <p:grpSpPr>
+        <a:xfrm>
+          <a:off x="0" y="0"/>
+          <a:ext cx="0" cy="0"/>
+          <a:chOff x="0" y="0"/>
+          <a:chExt cx="0" cy="0"/>
+        </a:xfrm>
+      </p:grpSpPr>
+      <p:sp>
+        <p:nvSpPr>
+          <p:cNvPr id="2" name="Slide Image Placeholder 1"/>
+          <p:cNvSpPr>
+            <a:spLocks noGrp="1" noRot="1" noChangeAspect="1"/>
+          </p:cNvSpPr>
+          <p:nvPr>
+            <p:ph type="sldImg"/>
+          </p:nvPr>
+        </p:nvSpPr>
+        <p:spPr/>
+      </p:sp>
+      <p:sp>
+        <p:nvSpPr>
+          <p:cNvPr id="3" name="Notes Placeholder 2"/>
+          <p:cNvSpPr>
+            <a:spLocks noGrp="1"/>
+          </p:cNvSpPr>
+          <p:nvPr>
+            <p:ph type="body" idx="1"/>
+          </p:nvPr>
+        </p:nvSpPr>
+        <p:spPr/>
+        <p:txBody>
+          <a:bodyPr/>
+          <a:lstStyle/>
+          <a:p>
+            <a:r>
+              <a:rPr lang="en-US" dirty="0"/>
+              <a:t>Three surfaces, one table. Point out that the log entry and the toggle are the same row, so deleting the entry is how you clear a flag.</a:t>
+            </a:r>
+            <a:endParaRPr lang="en-US" dirty="0"/>
+          </a:p>
+        </p:txBody>
+      </p:sp>
+      <p:sp>
+        <p:nvSpPr>
+          <p:cNvPr id="4" name="Slide Number Placeholder 3"/>
+          <p:cNvSpPr>
+            <a:spLocks noGrp="1"/>
+          </p:cNvSpPr>
+          <p:nvPr>
+            <p:ph type="sldNum" sz="quarter" idx="10"/>
+          </p:nvPr>
+        </p:nvSpPr>
+        <p:spPr/>
+        <p:txBody>
+          <a:bodyPr/>
+          <a:lstStyle/>
+          <a:p>
+            <a:fld id="{F7021451-1387-4CA6-816F-3879F97B5CBC}" type="slidenum">
+              <a:rPr lang="en-US"/>
+              <a:t>3</a:t>
+            </a:fld>
+            <a:endParaRPr lang="en-US"/>
+          </a:p>
+        </p:txBody>
+      </p:sp>
+    </p:spTree>
+    <p:extLst>
+      <p:ext uri="{BB962C8B-B14F-4D97-AF65-F5344CB8AC3E}">
+        <p14:creationId xmlns:p14="http://schemas.microsoft.com/office/powerpoint/2010/main" val="1024086991"/>
+      </p:ext>
+    </p:extLst>
+  </p:cSld>
+  <p:clrMapOvr>
+    <a:masterClrMapping/>
+  </p:clrMapOvr>
+</p:notes>
+</file>
+
+<file path=ppt/notesSlides/notesSlide16.xml><?xml version="1.0" encoding="utf-8"?>
+<p:notes xmlns:a="http://schemas.openxmlformats.org/drawingml/2006/main" xmlns:r="http://schemas.openxmlformats.org/officeDocument/2006/relationships" xmlns:p="http://schemas.openxmlformats.org/presentationml/2006/main">
+  <p:cSld>
+    <p:spTree>
+      <p:nvGrpSpPr>
+        <p:cNvPr id="1" name=""/>
+        <p:cNvGrpSpPr/>
+        <p:nvPr/>
+      </p:nvGrpSpPr>
+      <p:grpSpPr>
+        <a:xfrm>
+          <a:off x="0" y="0"/>
+          <a:ext cx="0" cy="0"/>
+          <a:chOff x="0" y="0"/>
+          <a:chExt cx="0" cy="0"/>
+        </a:xfrm>
+      </p:grpSpPr>
+      <p:sp>
+        <p:nvSpPr>
+          <p:cNvPr id="2" name="Slide Image Placeholder 1"/>
+          <p:cNvSpPr>
+            <a:spLocks noGrp="1" noRot="1" noChangeAspect="1"/>
+          </p:cNvSpPr>
+          <p:nvPr>
+            <p:ph type="sldImg"/>
+          </p:nvPr>
+        </p:nvSpPr>
+        <p:spPr/>
+      </p:sp>
+      <p:sp>
+        <p:nvSpPr>
+          <p:cNvPr id="3" name="Notes Placeholder 2"/>
+          <p:cNvSpPr>
+            <a:spLocks noGrp="1"/>
+          </p:cNvSpPr>
+          <p:nvPr>
+            <p:ph type="body" idx="1"/>
+          </p:nvPr>
+        </p:nvSpPr>
+        <p:spPr/>
+        <p:txBody>
+          <a:bodyPr/>
+          <a:lstStyle/>
+          <a:p>
+            <a:r>
+              <a:rPr lang="en-US" dirty="0"/>
+              <a:t>The only page not backed by the CRM database — it is here to show the workbook alongside the app's own charts, not to duplicate them.</a:t>
+            </a:r>
+            <a:endParaRPr lang="en-US" dirty="0"/>
+          </a:p>
+        </p:txBody>
+      </p:sp>
+      <p:sp>
+        <p:nvSpPr>
+          <p:cNvPr id="4" name="Slide Number Placeholder 3"/>
+          <p:cNvSpPr>
+            <a:spLocks noGrp="1"/>
+          </p:cNvSpPr>
+          <p:nvPr>
+            <p:ph type="sldNum" sz="quarter" idx="10"/>
+          </p:nvPr>
+        </p:nvSpPr>
+        <p:spPr/>
+        <p:txBody>
+          <a:bodyPr/>
+          <a:lstStyle/>
+          <a:p>
+            <a:fld id="{F7021451-1387-4CA6-816F-3879F97B5CBC}" type="slidenum">
+              <a:rPr lang="en-US"/>
+              <a:t>3</a:t>
             </a:fld>
             <a:endParaRPr lang="en-US"/>
           </a:p>
@@ -2015,7 +2460,7 @@
                 <a:ea typeface="Cambria" pitchFamily="34" charset="-122"/>
                 <a:cs typeface="Cambria" pitchFamily="34" charset="-120"/>
               </a:rPr>
-              <a:t>8</a:t>
+              <a:t>10</a:t>
             </a:r>
             <a:endParaRPr lang="en-US" sz="3400" dirty="0"/>
           </a:p>
@@ -2093,7 +2538,7 @@
                 <a:ea typeface="Cambria" pitchFamily="34" charset="-122"/>
                 <a:cs typeface="Cambria" pitchFamily="34" charset="-120"/>
               </a:rPr>
-              <a:t>6</a:t>
+              <a:t>9</a:t>
             </a:r>
             <a:endParaRPr lang="en-US" sz="3400" dirty="0"/>
           </a:p>
@@ -2171,7 +2616,7 @@
                 <a:ea typeface="Cambria" pitchFamily="34" charset="-122"/>
                 <a:cs typeface="Cambria" pitchFamily="34" charset="-120"/>
               </a:rPr>
-              <a:t>24</a:t>
+              <a:t>31</a:t>
             </a:r>
             <a:endParaRPr lang="en-US" sz="3400" dirty="0"/>
           </a:p>
@@ -2381,8 +2826,8 @@
         </p:blipFill>
         <p:spPr>
           <a:xfrm>
-            <a:off x="548640" y="1463040"/>
-            <a:ext cx="7589520" cy="4937760"/>
+            <a:off x="662054" y="1463040"/>
+            <a:ext cx="7362691" cy="4937760"/>
           </a:xfrm>
           <a:prstGeom prst="rect">
             <a:avLst/>
@@ -3244,7 +3689,7 @@
                 <a:ea typeface="Calibri" pitchFamily="34" charset="-122"/>
                 <a:cs typeface="Calibri" pitchFamily="34" charset="-120"/>
               </a:rPr>
-              <a:t>Moves as coursework</a:t>
+              <a:t>Authentication</a:t>
             </a:r>
             <a:endParaRPr lang="en-US" sz="1700" dirty="0"/>
           </a:p>
@@ -3283,7 +3728,7 @@
                 <a:ea typeface="Calibri" pitchFamily="34" charset="-122"/>
                 <a:cs typeface="Calibri" pitchFamily="34" charset="-120"/>
               </a:rPr>
-              <a:t>The richest unused data in the API, and the one item that is a schema project.</a:t>
+              <a:t>The acting-as switcher attributes writes but verifies nothing. Real auth replaces the body of one function, ownerFor().</a:t>
             </a:r>
             <a:endParaRPr lang="en-US" sz="1300" dirty="0"/>
           </a:p>
@@ -3462,6 +3907,2394 @@
               <a:t>Backlog lives in TODO.md · architecture and conventions in CLAUDE.md</a:t>
             </a:r>
             <a:endParaRPr lang="en-US" sz="1100" dirty="0"/>
+          </a:p>
+        </p:txBody>
+      </p:sp>
+    </p:spTree>
+  </p:cSld>
+  <p:clrMapOvr>
+    <a:masterClrMapping/>
+  </p:clrMapOvr>
+</p:sld>
+</file>
+
+<file path=ppt/slides/slide12.xml><?xml version="1.0" encoding="utf-8"?>
+<p:sld xmlns:a="http://schemas.openxmlformats.org/drawingml/2006/main" xmlns:r="http://schemas.openxmlformats.org/officeDocument/2006/relationships" xmlns:p="http://schemas.openxmlformats.org/presentationml/2006/main">
+  <p:cSld name="Slide 3">
+    <p:bg>
+      <p:bgPr>
+        <a:solidFill>
+          <a:srgbClr val="FFFFFF"/>
+        </a:solidFill>
+      </p:bgPr>
+    </p:bg>
+    <p:spTree>
+      <p:nvGrpSpPr>
+        <p:cNvPr id="1" name=""/>
+        <p:cNvGrpSpPr/>
+        <p:nvPr/>
+      </p:nvGrpSpPr>
+      <p:grpSpPr>
+        <a:xfrm>
+          <a:off x="0" y="0"/>
+          <a:ext cx="0" cy="0"/>
+          <a:chOff x="0" y="0"/>
+          <a:chExt cx="0" cy="0"/>
+        </a:xfrm>
+      </p:grpSpPr>
+      <p:sp>
+        <p:nvSpPr>
+          <p:cNvPr id="2" name="Text 0"/>
+          <p:cNvSpPr/>
+          <p:nvPr/>
+        </p:nvSpPr>
+        <p:spPr>
+          <a:xfrm>
+            <a:off x="548640" y="384048"/>
+            <a:ext cx="7863840" cy="566928"/>
+          </a:xfrm>
+          <a:prstGeom prst="rect">
+            <a:avLst/>
+          </a:prstGeom>
+          <a:noFill/>
+          <a:ln/>
+        </p:spPr>
+        <p:txBody>
+          <a:bodyPr wrap="square" lIns="0" tIns="0" rIns="0" bIns="0" rtlCol="0" anchor="ctr"/>
+          <a:lstStyle/>
+          <a:p>
+            <a:pPr indent="0" marL="0">
+              <a:buNone/>
+            </a:pPr>
+            <a:r>
+              <a:rPr lang="en-US" sz="3000" b="1" dirty="0">
+                <a:solidFill>
+                  <a:srgbClr val="0B0B0B"/>
+                </a:solidFill>
+                <a:latin typeface="Cambria" pitchFamily="34" charset="0"/>
+                <a:ea typeface="Cambria" pitchFamily="34" charset="-122"/>
+                <a:cs typeface="Cambria" pitchFamily="34" charset="-120"/>
+              </a:rPr>
+              <a:t>Moves — the course catalogue</a:t>
+            </a:r>
+            <a:endParaRPr lang="en-US" sz="3000" dirty="0"/>
+          </a:p>
+        </p:txBody>
+      </p:sp>
+      <p:sp>
+        <p:nvSpPr>
+          <p:cNvPr id="3" name="Text 1"/>
+          <p:cNvSpPr/>
+          <p:nvPr/>
+        </p:nvSpPr>
+        <p:spPr>
+          <a:xfrm>
+            <a:off x="548640" y="950976"/>
+            <a:ext cx="8778240" cy="365760"/>
+          </a:xfrm>
+          <a:prstGeom prst="rect">
+            <a:avLst/>
+          </a:prstGeom>
+          <a:noFill/>
+          <a:ln/>
+        </p:spPr>
+        <p:txBody>
+          <a:bodyPr wrap="square" lIns="0" tIns="0" rIns="0" bIns="0" rtlCol="0" anchor="ctr"/>
+          <a:lstStyle/>
+          <a:p>
+            <a:pPr indent="0" marL="0">
+              <a:buNone/>
+            </a:pPr>
+            <a:r>
+              <a:rPr lang="en-US" sz="1400" dirty="0">
+                <a:solidFill>
+                  <a:srgbClr val="52514E"/>
+                </a:solidFill>
+                <a:latin typeface="Calibri" pitchFamily="34" charset="0"/>
+                <a:ea typeface="Calibri" pitchFamily="34" charset="-122"/>
+                <a:cs typeface="Calibri" pitchFamily="34" charset="-120"/>
+              </a:rPr>
+              <a:t>Every move in the dataset, with the metadata a movepool is built from.</a:t>
+            </a:r>
+            <a:endParaRPr lang="en-US" sz="1400" dirty="0"/>
+          </a:p>
+        </p:txBody>
+      </p:sp>
+      <p:pic>
+        <p:nvPicPr>
+          <p:cNvPr id="4" name="Image 0" descr="preencoded.png">    </p:cNvPr>
+          <p:cNvPicPr>
+            <a:picLocks noChangeAspect="1"/>
+          </p:cNvPicPr>
+          <p:nvPr/>
+        </p:nvPicPr>
+        <p:blipFill>
+          <a:blip r:embed="rId1"/>
+          <a:stretch>
+            <a:fillRect/>
+          </a:stretch>
+        </p:blipFill>
+        <p:spPr>
+          <a:xfrm>
+            <a:off x="957507" y="1463040"/>
+            <a:ext cx="6771785" cy="4937760"/>
+          </a:xfrm>
+          <a:prstGeom prst="rect">
+            <a:avLst/>
+          </a:prstGeom>
+          <a:effectLst>
+            <a:outerShdw sx="100000" sy="100000" kx="0" ky="0" algn="bl" rotWithShape="0" blurRad="177800" dist="38100" dir="5400000">
+              <a:srgbClr val="000000">
+                <a:alpha val="18000"/>
+              </a:srgbClr>
+            </a:outerShdw>
+          </a:effectLst>
+        </p:spPr>
+      </p:pic>
+      <p:sp>
+        <p:nvSpPr>
+          <p:cNvPr id="5" name="Shape 2"/>
+          <p:cNvSpPr/>
+          <p:nvPr/>
+        </p:nvSpPr>
+        <p:spPr>
+          <a:xfrm>
+            <a:off x="8458200" y="1600200"/>
+            <a:ext cx="347472" cy="347472"/>
+          </a:xfrm>
+          <a:prstGeom prst="ellipse">
+            <a:avLst/>
+          </a:prstGeom>
+          <a:solidFill>
+            <a:srgbClr val="D92D20"/>
+          </a:solidFill>
+          <a:ln/>
+        </p:spPr>
+      </p:sp>
+      <p:sp>
+        <p:nvSpPr>
+          <p:cNvPr id="6" name="Text 3"/>
+          <p:cNvSpPr/>
+          <p:nvPr/>
+        </p:nvSpPr>
+        <p:spPr>
+          <a:xfrm>
+            <a:off x="8458200" y="1600200"/>
+            <a:ext cx="347472" cy="347472"/>
+          </a:xfrm>
+          <a:prstGeom prst="rect">
+            <a:avLst/>
+          </a:prstGeom>
+          <a:noFill/>
+          <a:ln/>
+        </p:spPr>
+        <p:txBody>
+          <a:bodyPr wrap="square" lIns="0" tIns="0" rIns="0" bIns="0" rtlCol="0" anchor="ctr"/>
+          <a:lstStyle/>
+          <a:p>
+            <a:pPr algn="ctr" indent="0" marL="0">
+              <a:buNone/>
+            </a:pPr>
+            <a:r>
+              <a:rPr lang="en-US" sz="1200" b="1" dirty="0">
+                <a:solidFill>
+                  <a:srgbClr val="FFFFFF"/>
+                </a:solidFill>
+                <a:latin typeface="Calibri" pitchFamily="34" charset="0"/>
+                <a:ea typeface="Calibri" pitchFamily="34" charset="-122"/>
+                <a:cs typeface="Calibri" pitchFamily="34" charset="-120"/>
+              </a:rPr>
+              <a:t>1</a:t>
+            </a:r>
+            <a:endParaRPr lang="en-US" sz="1200" dirty="0"/>
+          </a:p>
+        </p:txBody>
+      </p:sp>
+      <p:sp>
+        <p:nvSpPr>
+          <p:cNvPr id="7" name="Text 4"/>
+          <p:cNvSpPr/>
+          <p:nvPr/>
+        </p:nvSpPr>
+        <p:spPr>
+          <a:xfrm>
+            <a:off x="8942832" y="1563624"/>
+            <a:ext cx="2834640" cy="347472"/>
+          </a:xfrm>
+          <a:prstGeom prst="rect">
+            <a:avLst/>
+          </a:prstGeom>
+          <a:noFill/>
+          <a:ln/>
+        </p:spPr>
+        <p:txBody>
+          <a:bodyPr wrap="square" lIns="0" tIns="0" rIns="0" bIns="0" rtlCol="0" anchor="ctr"/>
+          <a:lstStyle/>
+          <a:p>
+            <a:pPr indent="0" marL="0">
+              <a:buNone/>
+            </a:pPr>
+            <a:r>
+              <a:rPr lang="en-US" sz="1500" b="1" dirty="0">
+                <a:solidFill>
+                  <a:srgbClr val="0B0B0B"/>
+                </a:solidFill>
+                <a:latin typeface="Calibri" pitchFamily="34" charset="0"/>
+                <a:ea typeface="Calibri" pitchFamily="34" charset="-122"/>
+                <a:cs typeface="Calibri" pitchFamily="34" charset="-120"/>
+              </a:rPr>
+              <a:t>Nullable is not zero</a:t>
+            </a:r>
+            <a:endParaRPr lang="en-US" sz="1500" dirty="0"/>
+          </a:p>
+        </p:txBody>
+      </p:sp>
+      <p:sp>
+        <p:nvSpPr>
+          <p:cNvPr id="8" name="Text 5"/>
+          <p:cNvSpPr/>
+          <p:nvPr/>
+        </p:nvSpPr>
+        <p:spPr>
+          <a:xfrm>
+            <a:off x="8458200" y="1892808"/>
+            <a:ext cx="3291840" cy="960120"/>
+          </a:xfrm>
+          <a:prstGeom prst="rect">
+            <a:avLst/>
+          </a:prstGeom>
+          <a:noFill/>
+          <a:ln/>
+        </p:spPr>
+        <p:txBody>
+          <a:bodyPr wrap="square" lIns="0" tIns="0" rIns="0" bIns="0" rtlCol="0" anchor="ctr"/>
+          <a:lstStyle/>
+          <a:p>
+            <a:pPr indent="0" marL="0">
+              <a:buNone/>
+            </a:pPr>
+            <a:r>
+              <a:rPr lang="en-US" sz="1250" dirty="0">
+                <a:solidFill>
+                  <a:srgbClr val="52514E"/>
+                </a:solidFill>
+                <a:latin typeface="Calibri" pitchFamily="34" charset="0"/>
+                <a:ea typeface="Calibri" pitchFamily="34" charset="-122"/>
+                <a:cs typeface="Calibri" pitchFamily="34" charset="-120"/>
+              </a:rPr>
+              <a:t>A status move has no power; a move that never misses has no accuracy. Both render as —, and neither is counted in a mean.</a:t>
+            </a:r>
+            <a:endParaRPr lang="en-US" sz="1250" dirty="0"/>
+          </a:p>
+        </p:txBody>
+      </p:sp>
+      <p:sp>
+        <p:nvSpPr>
+          <p:cNvPr id="9" name="Shape 6"/>
+          <p:cNvSpPr/>
+          <p:nvPr/>
+        </p:nvSpPr>
+        <p:spPr>
+          <a:xfrm>
+            <a:off x="8458200" y="3200400"/>
+            <a:ext cx="347472" cy="347472"/>
+          </a:xfrm>
+          <a:prstGeom prst="ellipse">
+            <a:avLst/>
+          </a:prstGeom>
+          <a:solidFill>
+            <a:srgbClr val="D92D20"/>
+          </a:solidFill>
+          <a:ln/>
+        </p:spPr>
+      </p:sp>
+      <p:sp>
+        <p:nvSpPr>
+          <p:cNvPr id="10" name="Text 7"/>
+          <p:cNvSpPr/>
+          <p:nvPr/>
+        </p:nvSpPr>
+        <p:spPr>
+          <a:xfrm>
+            <a:off x="8458200" y="3200400"/>
+            <a:ext cx="347472" cy="347472"/>
+          </a:xfrm>
+          <a:prstGeom prst="rect">
+            <a:avLst/>
+          </a:prstGeom>
+          <a:noFill/>
+          <a:ln/>
+        </p:spPr>
+        <p:txBody>
+          <a:bodyPr wrap="square" lIns="0" tIns="0" rIns="0" bIns="0" rtlCol="0" anchor="ctr"/>
+          <a:lstStyle/>
+          <a:p>
+            <a:pPr algn="ctr" indent="0" marL="0">
+              <a:buNone/>
+            </a:pPr>
+            <a:r>
+              <a:rPr lang="en-US" sz="1200" b="1" dirty="0">
+                <a:solidFill>
+                  <a:srgbClr val="FFFFFF"/>
+                </a:solidFill>
+                <a:latin typeface="Calibri" pitchFamily="34" charset="0"/>
+                <a:ea typeface="Calibri" pitchFamily="34" charset="-122"/>
+                <a:cs typeface="Calibri" pitchFamily="34" charset="-120"/>
+              </a:rPr>
+              <a:t>2</a:t>
+            </a:r>
+            <a:endParaRPr lang="en-US" sz="1200" dirty="0"/>
+          </a:p>
+        </p:txBody>
+      </p:sp>
+      <p:sp>
+        <p:nvSpPr>
+          <p:cNvPr id="11" name="Text 8"/>
+          <p:cNvSpPr/>
+          <p:nvPr/>
+        </p:nvSpPr>
+        <p:spPr>
+          <a:xfrm>
+            <a:off x="8942832" y="3163824"/>
+            <a:ext cx="2834640" cy="347472"/>
+          </a:xfrm>
+          <a:prstGeom prst="rect">
+            <a:avLst/>
+          </a:prstGeom>
+          <a:noFill/>
+          <a:ln/>
+        </p:spPr>
+        <p:txBody>
+          <a:bodyPr wrap="square" lIns="0" tIns="0" rIns="0" bIns="0" rtlCol="0" anchor="ctr"/>
+          <a:lstStyle/>
+          <a:p>
+            <a:pPr indent="0" marL="0">
+              <a:buNone/>
+            </a:pPr>
+            <a:r>
+              <a:rPr lang="en-US" sz="1500" b="1" dirty="0">
+                <a:solidFill>
+                  <a:srgbClr val="0B0B0B"/>
+                </a:solidFill>
+                <a:latin typeface="Calibri" pitchFamily="34" charset="0"/>
+                <a:ea typeface="Calibri" pitchFamily="34" charset="-122"/>
+                <a:cs typeface="Calibri" pitchFamily="34" charset="-120"/>
+              </a:rPr>
+              <a:t>Filter like the dex</a:t>
+            </a:r>
+            <a:endParaRPr lang="en-US" sz="1500" dirty="0"/>
+          </a:p>
+        </p:txBody>
+      </p:sp>
+      <p:sp>
+        <p:nvSpPr>
+          <p:cNvPr id="12" name="Text 9"/>
+          <p:cNvSpPr/>
+          <p:nvPr/>
+        </p:nvSpPr>
+        <p:spPr>
+          <a:xfrm>
+            <a:off x="8458200" y="3493008"/>
+            <a:ext cx="3291840" cy="960120"/>
+          </a:xfrm>
+          <a:prstGeom prst="rect">
+            <a:avLst/>
+          </a:prstGeom>
+          <a:noFill/>
+          <a:ln/>
+        </p:spPr>
+        <p:txBody>
+          <a:bodyPr wrap="square" lIns="0" tIns="0" rIns="0" bIns="0" rtlCol="0" anchor="ctr"/>
+          <a:lstStyle/>
+          <a:p>
+            <a:pPr indent="0" marL="0">
+              <a:buNone/>
+            </a:pPr>
+            <a:r>
+              <a:rPr lang="en-US" sz="1250" dirty="0">
+                <a:solidFill>
+                  <a:srgbClr val="52514E"/>
+                </a:solidFill>
+                <a:latin typeface="Calibri" pitchFamily="34" charset="0"/>
+                <a:ea typeface="Calibri" pitchFamily="34" charset="-122"/>
+                <a:cs typeface="Calibri" pitchFamily="34" charset="-120"/>
+              </a:rPr>
+              <a:t>Search, type, damage class, generation, learn method and a power range — all server-side, sorted and paginated.</a:t>
+            </a:r>
+            <a:endParaRPr lang="en-US" sz="1250" dirty="0"/>
+          </a:p>
+        </p:txBody>
+      </p:sp>
+      <p:sp>
+        <p:nvSpPr>
+          <p:cNvPr id="13" name="Shape 10"/>
+          <p:cNvSpPr/>
+          <p:nvPr/>
+        </p:nvSpPr>
+        <p:spPr>
+          <a:xfrm>
+            <a:off x="8458200" y="4800600"/>
+            <a:ext cx="347472" cy="347472"/>
+          </a:xfrm>
+          <a:prstGeom prst="ellipse">
+            <a:avLst/>
+          </a:prstGeom>
+          <a:solidFill>
+            <a:srgbClr val="D92D20"/>
+          </a:solidFill>
+          <a:ln/>
+        </p:spPr>
+      </p:sp>
+      <p:sp>
+        <p:nvSpPr>
+          <p:cNvPr id="14" name="Text 11"/>
+          <p:cNvSpPr/>
+          <p:nvPr/>
+        </p:nvSpPr>
+        <p:spPr>
+          <a:xfrm>
+            <a:off x="8458200" y="4800600"/>
+            <a:ext cx="347472" cy="347472"/>
+          </a:xfrm>
+          <a:prstGeom prst="rect">
+            <a:avLst/>
+          </a:prstGeom>
+          <a:noFill/>
+          <a:ln/>
+        </p:spPr>
+        <p:txBody>
+          <a:bodyPr wrap="square" lIns="0" tIns="0" rIns="0" bIns="0" rtlCol="0" anchor="ctr"/>
+          <a:lstStyle/>
+          <a:p>
+            <a:pPr algn="ctr" indent="0" marL="0">
+              <a:buNone/>
+            </a:pPr>
+            <a:r>
+              <a:rPr lang="en-US" sz="1200" b="1" dirty="0">
+                <a:solidFill>
+                  <a:srgbClr val="FFFFFF"/>
+                </a:solidFill>
+                <a:latin typeface="Calibri" pitchFamily="34" charset="0"/>
+                <a:ea typeface="Calibri" pitchFamily="34" charset="-122"/>
+                <a:cs typeface="Calibri" pitchFamily="34" charset="-120"/>
+              </a:rPr>
+              <a:t>3</a:t>
+            </a:r>
+            <a:endParaRPr lang="en-US" sz="1200" dirty="0"/>
+          </a:p>
+        </p:txBody>
+      </p:sp>
+      <p:sp>
+        <p:nvSpPr>
+          <p:cNvPr id="15" name="Text 12"/>
+          <p:cNvSpPr/>
+          <p:nvPr/>
+        </p:nvSpPr>
+        <p:spPr>
+          <a:xfrm>
+            <a:off x="8942832" y="4764024"/>
+            <a:ext cx="2834640" cy="347472"/>
+          </a:xfrm>
+          <a:prstGeom prst="rect">
+            <a:avLst/>
+          </a:prstGeom>
+          <a:noFill/>
+          <a:ln/>
+        </p:spPr>
+        <p:txBody>
+          <a:bodyPr wrap="square" lIns="0" tIns="0" rIns="0" bIns="0" rtlCol="0" anchor="ctr"/>
+          <a:lstStyle/>
+          <a:p>
+            <a:pPr indent="0" marL="0">
+              <a:buNone/>
+            </a:pPr>
+            <a:r>
+              <a:rPr lang="en-US" sz="1500" b="1" dirty="0">
+                <a:solidFill>
+                  <a:srgbClr val="0B0B0B"/>
+                </a:solidFill>
+                <a:latin typeface="Calibri" pitchFamily="34" charset="0"/>
+                <a:ea typeface="Calibri" pitchFamily="34" charset="-122"/>
+                <a:cs typeface="Calibri" pitchFamily="34" charset="-120"/>
+              </a:rPr>
+              <a:t>Scoped to a roster</a:t>
+            </a:r>
+            <a:endParaRPr lang="en-US" sz="1500" dirty="0"/>
+          </a:p>
+        </p:txBody>
+      </p:sp>
+      <p:sp>
+        <p:nvSpPr>
+          <p:cNvPr id="16" name="Text 13"/>
+          <p:cNvSpPr/>
+          <p:nvPr/>
+        </p:nvSpPr>
+        <p:spPr>
+          <a:xfrm>
+            <a:off x="8458200" y="5093208"/>
+            <a:ext cx="3291840" cy="960120"/>
+          </a:xfrm>
+          <a:prstGeom prst="rect">
+            <a:avLst/>
+          </a:prstGeom>
+          <a:noFill/>
+          <a:ln/>
+        </p:spPr>
+        <p:txBody>
+          <a:bodyPr wrap="square" lIns="0" tIns="0" rIns="0" bIns="0" rtlCol="0" anchor="ctr"/>
+          <a:lstStyle/>
+          <a:p>
+            <a:pPr indent="0" marL="0">
+              <a:buNone/>
+            </a:pPr>
+            <a:r>
+              <a:rPr lang="en-US" sz="1250" dirty="0">
+                <a:solidFill>
+                  <a:srgbClr val="52514E"/>
+                </a:solidFill>
+                <a:latin typeface="Calibri" pitchFamily="34" charset="0"/>
+                <a:ea typeface="Calibri" pitchFamily="34" charset="-122"/>
+                <a:cs typeface="Calibri" pitchFamily="34" charset="-120"/>
+              </a:rPr>
+              <a:t>Arrive from a Pokémon or a trainer and the catalogue narrows to what they can actually learn.</a:t>
+            </a:r>
+            <a:endParaRPr lang="en-US" sz="1250" dirty="0"/>
+          </a:p>
+        </p:txBody>
+      </p:sp>
+    </p:spTree>
+  </p:cSld>
+  <p:clrMapOvr>
+    <a:masterClrMapping/>
+  </p:clrMapOvr>
+</p:sld>
+</file>
+
+<file path=ppt/slides/slide13.xml><?xml version="1.0" encoding="utf-8"?>
+<p:sld xmlns:a="http://schemas.openxmlformats.org/drawingml/2006/main" xmlns:r="http://schemas.openxmlformats.org/officeDocument/2006/relationships" xmlns:p="http://schemas.openxmlformats.org/presentationml/2006/main">
+  <p:cSld name="Slide 3">
+    <p:bg>
+      <p:bgPr>
+        <a:solidFill>
+          <a:srgbClr val="FFFFFF"/>
+        </a:solidFill>
+      </p:bgPr>
+    </p:bg>
+    <p:spTree>
+      <p:nvGrpSpPr>
+        <p:cNvPr id="1" name=""/>
+        <p:cNvGrpSpPr/>
+        <p:nvPr/>
+      </p:nvGrpSpPr>
+      <p:grpSpPr>
+        <a:xfrm>
+          <a:off x="0" y="0"/>
+          <a:ext cx="0" cy="0"/>
+          <a:chOff x="0" y="0"/>
+          <a:chExt cx="0" cy="0"/>
+        </a:xfrm>
+      </p:grpSpPr>
+      <p:sp>
+        <p:nvSpPr>
+          <p:cNvPr id="2" name="Text 0"/>
+          <p:cNvSpPr/>
+          <p:nvPr/>
+        </p:nvSpPr>
+        <p:spPr>
+          <a:xfrm>
+            <a:off x="548640" y="384048"/>
+            <a:ext cx="7863840" cy="566928"/>
+          </a:xfrm>
+          <a:prstGeom prst="rect">
+            <a:avLst/>
+          </a:prstGeom>
+          <a:noFill/>
+          <a:ln/>
+        </p:spPr>
+        <p:txBody>
+          <a:bodyPr wrap="square" lIns="0" tIns="0" rIns="0" bIns="0" rtlCol="0" anchor="ctr"/>
+          <a:lstStyle/>
+          <a:p>
+            <a:pPr indent="0" marL="0">
+              <a:buNone/>
+            </a:pPr>
+            <a:r>
+              <a:rPr lang="en-US" sz="3000" b="1" dirty="0">
+                <a:solidFill>
+                  <a:srgbClr val="0B0B0B"/>
+                </a:solidFill>
+                <a:latin typeface="Cambria" pitchFamily="34" charset="0"/>
+                <a:ea typeface="Cambria" pitchFamily="34" charset="-122"/>
+                <a:cs typeface="Cambria" pitchFamily="34" charset="-120"/>
+              </a:rPr>
+              <a:t>One move — who learns it, and how</a:t>
+            </a:r>
+            <a:endParaRPr lang="en-US" sz="3000" dirty="0"/>
+          </a:p>
+        </p:txBody>
+      </p:sp>
+      <p:sp>
+        <p:nvSpPr>
+          <p:cNvPr id="3" name="Text 1"/>
+          <p:cNvSpPr/>
+          <p:nvPr/>
+        </p:nvSpPr>
+        <p:spPr>
+          <a:xfrm>
+            <a:off x="548640" y="950976"/>
+            <a:ext cx="8778240" cy="365760"/>
+          </a:xfrm>
+          <a:prstGeom prst="rect">
+            <a:avLst/>
+          </a:prstGeom>
+          <a:noFill/>
+          <a:ln/>
+        </p:spPr>
+        <p:txBody>
+          <a:bodyPr wrap="square" lIns="0" tIns="0" rIns="0" bIns="0" rtlCol="0" anchor="ctr"/>
+          <a:lstStyle/>
+          <a:p>
+            <a:pPr indent="0" marL="0">
+              <a:buNone/>
+            </a:pPr>
+            <a:r>
+              <a:rPr lang="en-US" sz="1400" dirty="0">
+                <a:solidFill>
+                  <a:srgbClr val="52514E"/>
+                </a:solidFill>
+                <a:latin typeface="Calibri" pitchFamily="34" charset="0"/>
+                <a:ea typeface="Calibri" pitchFamily="34" charset="-122"/>
+                <a:cs typeface="Calibri" pitchFamily="34" charset="-120"/>
+              </a:rPr>
+              <a:t>Every route into a move, and the trainers who could field it.</a:t>
+            </a:r>
+            <a:endParaRPr lang="en-US" sz="1400" dirty="0"/>
+          </a:p>
+        </p:txBody>
+      </p:sp>
+      <p:pic>
+        <p:nvPicPr>
+          <p:cNvPr id="4" name="Image 0" descr="preencoded.png">    </p:cNvPr>
+          <p:cNvPicPr>
+            <a:picLocks noChangeAspect="1"/>
+          </p:cNvPicPr>
+          <p:nvPr/>
+        </p:nvPicPr>
+        <p:blipFill>
+          <a:blip r:embed="rId1"/>
+          <a:stretch>
+            <a:fillRect/>
+          </a:stretch>
+        </p:blipFill>
+        <p:spPr>
+          <a:xfrm>
+            <a:off x="957507" y="1463040"/>
+            <a:ext cx="6771785" cy="4937760"/>
+          </a:xfrm>
+          <a:prstGeom prst="rect">
+            <a:avLst/>
+          </a:prstGeom>
+          <a:effectLst>
+            <a:outerShdw sx="100000" sy="100000" kx="0" ky="0" algn="bl" rotWithShape="0" blurRad="177800" dist="38100" dir="5400000">
+              <a:srgbClr val="000000">
+                <a:alpha val="18000"/>
+              </a:srgbClr>
+            </a:outerShdw>
+          </a:effectLst>
+        </p:spPr>
+      </p:pic>
+      <p:sp>
+        <p:nvSpPr>
+          <p:cNvPr id="5" name="Shape 2"/>
+          <p:cNvSpPr/>
+          <p:nvPr/>
+        </p:nvSpPr>
+        <p:spPr>
+          <a:xfrm>
+            <a:off x="8458200" y="1600200"/>
+            <a:ext cx="347472" cy="347472"/>
+          </a:xfrm>
+          <a:prstGeom prst="ellipse">
+            <a:avLst/>
+          </a:prstGeom>
+          <a:solidFill>
+            <a:srgbClr val="D92D20"/>
+          </a:solidFill>
+          <a:ln/>
+        </p:spPr>
+      </p:sp>
+      <p:sp>
+        <p:nvSpPr>
+          <p:cNvPr id="6" name="Text 3"/>
+          <p:cNvSpPr/>
+          <p:nvPr/>
+        </p:nvSpPr>
+        <p:spPr>
+          <a:xfrm>
+            <a:off x="8458200" y="1600200"/>
+            <a:ext cx="347472" cy="347472"/>
+          </a:xfrm>
+          <a:prstGeom prst="rect">
+            <a:avLst/>
+          </a:prstGeom>
+          <a:noFill/>
+          <a:ln/>
+        </p:spPr>
+        <p:txBody>
+          <a:bodyPr wrap="square" lIns="0" tIns="0" rIns="0" bIns="0" rtlCol="0" anchor="ctr"/>
+          <a:lstStyle/>
+          <a:p>
+            <a:pPr algn="ctr" indent="0" marL="0">
+              <a:buNone/>
+            </a:pPr>
+            <a:r>
+              <a:rPr lang="en-US" sz="1200" b="1" dirty="0">
+                <a:solidFill>
+                  <a:srgbClr val="FFFFFF"/>
+                </a:solidFill>
+                <a:latin typeface="Calibri" pitchFamily="34" charset="0"/>
+                <a:ea typeface="Calibri" pitchFamily="34" charset="-122"/>
+                <a:cs typeface="Calibri" pitchFamily="34" charset="-120"/>
+              </a:rPr>
+              <a:t>1</a:t>
+            </a:r>
+            <a:endParaRPr lang="en-US" sz="1200" dirty="0"/>
+          </a:p>
+        </p:txBody>
+      </p:sp>
+      <p:sp>
+        <p:nvSpPr>
+          <p:cNvPr id="7" name="Text 4"/>
+          <p:cNvSpPr/>
+          <p:nvPr/>
+        </p:nvSpPr>
+        <p:spPr>
+          <a:xfrm>
+            <a:off x="8942832" y="1563624"/>
+            <a:ext cx="2834640" cy="347472"/>
+          </a:xfrm>
+          <a:prstGeom prst="rect">
+            <a:avLst/>
+          </a:prstGeom>
+          <a:noFill/>
+          <a:ln/>
+        </p:spPr>
+        <p:txBody>
+          <a:bodyPr wrap="square" lIns="0" tIns="0" rIns="0" bIns="0" rtlCol="0" anchor="ctr"/>
+          <a:lstStyle/>
+          <a:p>
+            <a:pPr indent="0" marL="0">
+              <a:buNone/>
+            </a:pPr>
+            <a:r>
+              <a:rPr lang="en-US" sz="1500" b="1" dirty="0">
+                <a:solidFill>
+                  <a:srgbClr val="0B0B0B"/>
+                </a:solidFill>
+                <a:latin typeface="Calibri" pitchFamily="34" charset="0"/>
+                <a:ea typeface="Calibri" pitchFamily="34" charset="-122"/>
+                <a:cs typeface="Calibri" pitchFamily="34" charset="-120"/>
+              </a:rPr>
+              <a:t>Routes, counted</a:t>
+            </a:r>
+            <a:endParaRPr lang="en-US" sz="1500" dirty="0"/>
+          </a:p>
+        </p:txBody>
+      </p:sp>
+      <p:sp>
+        <p:nvSpPr>
+          <p:cNvPr id="8" name="Text 5"/>
+          <p:cNvSpPr/>
+          <p:nvPr/>
+        </p:nvSpPr>
+        <p:spPr>
+          <a:xfrm>
+            <a:off x="8458200" y="1892808"/>
+            <a:ext cx="3291840" cy="960120"/>
+          </a:xfrm>
+          <a:prstGeom prst="rect">
+            <a:avLst/>
+          </a:prstGeom>
+          <a:noFill/>
+          <a:ln/>
+        </p:spPr>
+        <p:txBody>
+          <a:bodyPr wrap="square" lIns="0" tIns="0" rIns="0" bIns="0" rtlCol="0" anchor="ctr"/>
+          <a:lstStyle/>
+          <a:p>
+            <a:pPr indent="0" marL="0">
+              <a:buNone/>
+            </a:pPr>
+            <a:r>
+              <a:rPr lang="en-US" sz="1250" dirty="0">
+                <a:solidFill>
+                  <a:srgbClr val="52514E"/>
+                </a:solidFill>
+                <a:latin typeface="Calibri" pitchFamily="34" charset="0"/>
+                <a:ea typeface="Calibri" pitchFamily="34" charset="-122"/>
+                <a:cs typeface="Calibri" pitchFamily="34" charset="-120"/>
+              </a:rPr>
+              <a:t>TM, tutor, egg, training and level-up each carry their own count, with a mean level where levels apply.</a:t>
+            </a:r>
+            <a:endParaRPr lang="en-US" sz="1250" dirty="0"/>
+          </a:p>
+        </p:txBody>
+      </p:sp>
+      <p:sp>
+        <p:nvSpPr>
+          <p:cNvPr id="9" name="Shape 6"/>
+          <p:cNvSpPr/>
+          <p:nvPr/>
+        </p:nvSpPr>
+        <p:spPr>
+          <a:xfrm>
+            <a:off x="8458200" y="3200400"/>
+            <a:ext cx="347472" cy="347472"/>
+          </a:xfrm>
+          <a:prstGeom prst="ellipse">
+            <a:avLst/>
+          </a:prstGeom>
+          <a:solidFill>
+            <a:srgbClr val="D92D20"/>
+          </a:solidFill>
+          <a:ln/>
+        </p:spPr>
+      </p:sp>
+      <p:sp>
+        <p:nvSpPr>
+          <p:cNvPr id="10" name="Text 7"/>
+          <p:cNvSpPr/>
+          <p:nvPr/>
+        </p:nvSpPr>
+        <p:spPr>
+          <a:xfrm>
+            <a:off x="8458200" y="3200400"/>
+            <a:ext cx="347472" cy="347472"/>
+          </a:xfrm>
+          <a:prstGeom prst="rect">
+            <a:avLst/>
+          </a:prstGeom>
+          <a:noFill/>
+          <a:ln/>
+        </p:spPr>
+        <p:txBody>
+          <a:bodyPr wrap="square" lIns="0" tIns="0" rIns="0" bIns="0" rtlCol="0" anchor="ctr"/>
+          <a:lstStyle/>
+          <a:p>
+            <a:pPr algn="ctr" indent="0" marL="0">
+              <a:buNone/>
+            </a:pPr>
+            <a:r>
+              <a:rPr lang="en-US" sz="1200" b="1" dirty="0">
+                <a:solidFill>
+                  <a:srgbClr val="FFFFFF"/>
+                </a:solidFill>
+                <a:latin typeface="Calibri" pitchFamily="34" charset="0"/>
+                <a:ea typeface="Calibri" pitchFamily="34" charset="-122"/>
+                <a:cs typeface="Calibri" pitchFamily="34" charset="-120"/>
+              </a:rPr>
+              <a:t>2</a:t>
+            </a:r>
+            <a:endParaRPr lang="en-US" sz="1200" dirty="0"/>
+          </a:p>
+        </p:txBody>
+      </p:sp>
+      <p:sp>
+        <p:nvSpPr>
+          <p:cNvPr id="11" name="Text 8"/>
+          <p:cNvSpPr/>
+          <p:nvPr/>
+        </p:nvSpPr>
+        <p:spPr>
+          <a:xfrm>
+            <a:off x="8942832" y="3163824"/>
+            <a:ext cx="2834640" cy="347472"/>
+          </a:xfrm>
+          <a:prstGeom prst="rect">
+            <a:avLst/>
+          </a:prstGeom>
+          <a:noFill/>
+          <a:ln/>
+        </p:spPr>
+        <p:txBody>
+          <a:bodyPr wrap="square" lIns="0" tIns="0" rIns="0" bIns="0" rtlCol="0" anchor="ctr"/>
+          <a:lstStyle/>
+          <a:p>
+            <a:pPr indent="0" marL="0">
+              <a:buNone/>
+            </a:pPr>
+            <a:r>
+              <a:rPr lang="en-US" sz="1500" b="1" dirty="0">
+                <a:solidFill>
+                  <a:srgbClr val="0B0B0B"/>
+                </a:solidFill>
+                <a:latin typeface="Calibri" pitchFamily="34" charset="0"/>
+                <a:ea typeface="Calibri" pitchFamily="34" charset="-122"/>
+                <a:cs typeface="Calibri" pitchFamily="34" charset="-120"/>
+              </a:rPr>
+              <a:t>Coverage, not just power</a:t>
+            </a:r>
+            <a:endParaRPr lang="en-US" sz="1500" dirty="0"/>
+          </a:p>
+        </p:txBody>
+      </p:sp>
+      <p:sp>
+        <p:nvSpPr>
+          <p:cNvPr id="12" name="Text 9"/>
+          <p:cNvSpPr/>
+          <p:nvPr/>
+        </p:nvSpPr>
+        <p:spPr>
+          <a:xfrm>
+            <a:off x="8458200" y="3493008"/>
+            <a:ext cx="3291840" cy="960120"/>
+          </a:xfrm>
+          <a:prstGeom prst="rect">
+            <a:avLst/>
+          </a:prstGeom>
+          <a:noFill/>
+          <a:ln/>
+        </p:spPr>
+        <p:txBody>
+          <a:bodyPr wrap="square" lIns="0" tIns="0" rIns="0" bIns="0" rtlCol="0" anchor="ctr"/>
+          <a:lstStyle/>
+          <a:p>
+            <a:pPr indent="0" marL="0">
+              <a:buNone/>
+            </a:pPr>
+            <a:r>
+              <a:rPr lang="en-US" sz="1250" dirty="0">
+                <a:solidFill>
+                  <a:srgbClr val="52514E"/>
+                </a:solidFill>
+                <a:latin typeface="Calibri" pitchFamily="34" charset="0"/>
+                <a:ea typeface="Calibri" pitchFamily="34" charset="-122"/>
+                <a:cs typeface="Calibri" pitchFamily="34" charset="-120"/>
+              </a:rPr>
+              <a:t>Which types learn it, and a STAB marker on learners whose own type matches the move.</a:t>
+            </a:r>
+            <a:endParaRPr lang="en-US" sz="1250" dirty="0"/>
+          </a:p>
+        </p:txBody>
+      </p:sp>
+      <p:sp>
+        <p:nvSpPr>
+          <p:cNvPr id="13" name="Shape 10"/>
+          <p:cNvSpPr/>
+          <p:nvPr/>
+        </p:nvSpPr>
+        <p:spPr>
+          <a:xfrm>
+            <a:off x="8458200" y="4800600"/>
+            <a:ext cx="347472" cy="347472"/>
+          </a:xfrm>
+          <a:prstGeom prst="ellipse">
+            <a:avLst/>
+          </a:prstGeom>
+          <a:solidFill>
+            <a:srgbClr val="D92D20"/>
+          </a:solidFill>
+          <a:ln/>
+        </p:spPr>
+      </p:sp>
+      <p:sp>
+        <p:nvSpPr>
+          <p:cNvPr id="14" name="Text 11"/>
+          <p:cNvSpPr/>
+          <p:nvPr/>
+        </p:nvSpPr>
+        <p:spPr>
+          <a:xfrm>
+            <a:off x="8458200" y="4800600"/>
+            <a:ext cx="347472" cy="347472"/>
+          </a:xfrm>
+          <a:prstGeom prst="rect">
+            <a:avLst/>
+          </a:prstGeom>
+          <a:noFill/>
+          <a:ln/>
+        </p:spPr>
+        <p:txBody>
+          <a:bodyPr wrap="square" lIns="0" tIns="0" rIns="0" bIns="0" rtlCol="0" anchor="ctr"/>
+          <a:lstStyle/>
+          <a:p>
+            <a:pPr algn="ctr" indent="0" marL="0">
+              <a:buNone/>
+            </a:pPr>
+            <a:r>
+              <a:rPr lang="en-US" sz="1200" b="1" dirty="0">
+                <a:solidFill>
+                  <a:srgbClr val="FFFFFF"/>
+                </a:solidFill>
+                <a:latin typeface="Calibri" pitchFamily="34" charset="0"/>
+                <a:ea typeface="Calibri" pitchFamily="34" charset="-122"/>
+                <a:cs typeface="Calibri" pitchFamily="34" charset="-120"/>
+              </a:rPr>
+              <a:t>3</a:t>
+            </a:r>
+            <a:endParaRPr lang="en-US" sz="1200" dirty="0"/>
+          </a:p>
+        </p:txBody>
+      </p:sp>
+      <p:sp>
+        <p:nvSpPr>
+          <p:cNvPr id="15" name="Text 12"/>
+          <p:cNvSpPr/>
+          <p:nvPr/>
+        </p:nvSpPr>
+        <p:spPr>
+          <a:xfrm>
+            <a:off x="8942832" y="4764024"/>
+            <a:ext cx="2834640" cy="347472"/>
+          </a:xfrm>
+          <a:prstGeom prst="rect">
+            <a:avLst/>
+          </a:prstGeom>
+          <a:noFill/>
+          <a:ln/>
+        </p:spPr>
+        <p:txBody>
+          <a:bodyPr wrap="square" lIns="0" tIns="0" rIns="0" bIns="0" rtlCol="0" anchor="ctr"/>
+          <a:lstStyle/>
+          <a:p>
+            <a:pPr indent="0" marL="0">
+              <a:buNone/>
+            </a:pPr>
+            <a:r>
+              <a:rPr lang="en-US" sz="1500" b="1" dirty="0">
+                <a:solidFill>
+                  <a:srgbClr val="0B0B0B"/>
+                </a:solidFill>
+                <a:latin typeface="Calibri" pitchFamily="34" charset="0"/>
+                <a:ea typeface="Calibri" pitchFamily="34" charset="-122"/>
+                <a:cs typeface="Calibri" pitchFamily="34" charset="-120"/>
+              </a:rPr>
+              <a:t>Counted in scope</a:t>
+            </a:r>
+            <a:endParaRPr lang="en-US" sz="1500" dirty="0"/>
+          </a:p>
+        </p:txBody>
+      </p:sp>
+      <p:sp>
+        <p:nvSpPr>
+          <p:cNvPr id="16" name="Text 13"/>
+          <p:cNvSpPr/>
+          <p:nvPr/>
+        </p:nvSpPr>
+        <p:spPr>
+          <a:xfrm>
+            <a:off x="8458200" y="5093208"/>
+            <a:ext cx="3291840" cy="960120"/>
+          </a:xfrm>
+          <a:prstGeom prst="rect">
+            <a:avLst/>
+          </a:prstGeom>
+          <a:noFill/>
+          <a:ln/>
+        </p:spPr>
+        <p:txBody>
+          <a:bodyPr wrap="square" lIns="0" tIns="0" rIns="0" bIns="0" rtlCol="0" anchor="ctr"/>
+          <a:lstStyle/>
+          <a:p>
+            <a:pPr indent="0" marL="0">
+              <a:buNone/>
+            </a:pPr>
+            <a:r>
+              <a:rPr lang="en-US" sz="1250" dirty="0">
+                <a:solidFill>
+                  <a:srgbClr val="52514E"/>
+                </a:solidFill>
+                <a:latin typeface="Calibri" pitchFamily="34" charset="0"/>
+                <a:ea typeface="Calibri" pitchFamily="34" charset="-122"/>
+                <a:cs typeface="Calibri" pitchFamily="34" charset="-120"/>
+              </a:rPr>
+              <a:t>Learners inside a filter are counted from the join rows — the dex-wide column would answer a different question.</a:t>
+            </a:r>
+            <a:endParaRPr lang="en-US" sz="1250" dirty="0"/>
+          </a:p>
+        </p:txBody>
+      </p:sp>
+    </p:spTree>
+  </p:cSld>
+  <p:clrMapOvr>
+    <a:masterClrMapping/>
+  </p:clrMapOvr>
+</p:sld>
+</file>
+
+<file path=ppt/slides/slide14.xml><?xml version="1.0" encoding="utf-8"?>
+<p:sld xmlns:a="http://schemas.openxmlformats.org/drawingml/2006/main" xmlns:r="http://schemas.openxmlformats.org/officeDocument/2006/relationships" xmlns:p="http://schemas.openxmlformats.org/presentationml/2006/main">
+  <p:cSld name="Slide 3">
+    <p:bg>
+      <p:bgPr>
+        <a:solidFill>
+          <a:srgbClr val="FFFFFF"/>
+        </a:solidFill>
+      </p:bgPr>
+    </p:bg>
+    <p:spTree>
+      <p:nvGrpSpPr>
+        <p:cNvPr id="1" name=""/>
+        <p:cNvGrpSpPr/>
+        <p:nvPr/>
+      </p:nvGrpSpPr>
+      <p:grpSpPr>
+        <a:xfrm>
+          <a:off x="0" y="0"/>
+          <a:ext cx="0" cy="0"/>
+          <a:chOff x="0" y="0"/>
+          <a:chExt cx="0" cy="0"/>
+        </a:xfrm>
+      </p:grpSpPr>
+      <p:sp>
+        <p:nvSpPr>
+          <p:cNvPr id="2" name="Text 0"/>
+          <p:cNvSpPr/>
+          <p:nvPr/>
+        </p:nvSpPr>
+        <p:spPr>
+          <a:xfrm>
+            <a:off x="548640" y="384048"/>
+            <a:ext cx="7863840" cy="566928"/>
+          </a:xfrm>
+          <a:prstGeom prst="rect">
+            <a:avLst/>
+          </a:prstGeom>
+          <a:noFill/>
+          <a:ln/>
+        </p:spPr>
+        <p:txBody>
+          <a:bodyPr wrap="square" lIns="0" tIns="0" rIns="0" bIns="0" rtlCol="0" anchor="ctr"/>
+          <a:lstStyle/>
+          <a:p>
+            <a:pPr indent="0" marL="0">
+              <a:buNone/>
+            </a:pPr>
+            <a:r>
+              <a:rPr lang="en-US" sz="3000" b="1" dirty="0">
+                <a:solidFill>
+                  <a:srgbClr val="0B0B0B"/>
+                </a:solidFill>
+                <a:latin typeface="Cambria" pitchFamily="34" charset="0"/>
+                <a:ea typeface="Cambria" pitchFamily="34" charset="-122"/>
+                <a:cs typeface="Cambria" pitchFamily="34" charset="-120"/>
+              </a:rPr>
+              <a:t>Notes — the written record</a:t>
+            </a:r>
+            <a:endParaRPr lang="en-US" sz="3000" dirty="0"/>
+          </a:p>
+        </p:txBody>
+      </p:sp>
+      <p:sp>
+        <p:nvSpPr>
+          <p:cNvPr id="3" name="Text 1"/>
+          <p:cNvSpPr/>
+          <p:nvPr/>
+        </p:nvSpPr>
+        <p:spPr>
+          <a:xfrm>
+            <a:off x="548640" y="950976"/>
+            <a:ext cx="8778240" cy="365760"/>
+          </a:xfrm>
+          <a:prstGeom prst="rect">
+            <a:avLst/>
+          </a:prstGeom>
+          <a:noFill/>
+          <a:ln/>
+        </p:spPr>
+        <p:txBody>
+          <a:bodyPr wrap="square" lIns="0" tIns="0" rIns="0" bIns="0" rtlCol="0" anchor="ctr"/>
+          <a:lstStyle/>
+          <a:p>
+            <a:pPr indent="0" marL="0">
+              <a:buNone/>
+            </a:pPr>
+            <a:r>
+              <a:rPr lang="en-US" sz="1400" dirty="0">
+                <a:solidFill>
+                  <a:srgbClr val="52514E"/>
+                </a:solidFill>
+                <a:latin typeface="Calibri" pitchFamily="34" charset="0"/>
+                <a:ea typeface="Calibri" pitchFamily="34" charset="-122"/>
+                <a:cs typeface="Calibri" pitchFamily="34" charset="-120"/>
+              </a:rPr>
+              <a:t>Every note across every Pokémon, in one filterable feed.</a:t>
+            </a:r>
+            <a:endParaRPr lang="en-US" sz="1400" dirty="0"/>
+          </a:p>
+        </p:txBody>
+      </p:sp>
+      <p:pic>
+        <p:nvPicPr>
+          <p:cNvPr id="4" name="Image 0" descr="preencoded.png">    </p:cNvPr>
+          <p:cNvPicPr>
+            <a:picLocks noChangeAspect="1"/>
+          </p:cNvPicPr>
+          <p:nvPr/>
+        </p:nvPicPr>
+        <p:blipFill>
+          <a:blip r:embed="rId1"/>
+          <a:stretch>
+            <a:fillRect/>
+          </a:stretch>
+        </p:blipFill>
+        <p:spPr>
+          <a:xfrm>
+            <a:off x="957507" y="1463040"/>
+            <a:ext cx="6771785" cy="4937760"/>
+          </a:xfrm>
+          <a:prstGeom prst="rect">
+            <a:avLst/>
+          </a:prstGeom>
+          <a:effectLst>
+            <a:outerShdw sx="100000" sy="100000" kx="0" ky="0" algn="bl" rotWithShape="0" blurRad="177800" dist="38100" dir="5400000">
+              <a:srgbClr val="000000">
+                <a:alpha val="18000"/>
+              </a:srgbClr>
+            </a:outerShdw>
+          </a:effectLst>
+        </p:spPr>
+      </p:pic>
+      <p:sp>
+        <p:nvSpPr>
+          <p:cNvPr id="5" name="Shape 2"/>
+          <p:cNvSpPr/>
+          <p:nvPr/>
+        </p:nvSpPr>
+        <p:spPr>
+          <a:xfrm>
+            <a:off x="8458200" y="1600200"/>
+            <a:ext cx="347472" cy="347472"/>
+          </a:xfrm>
+          <a:prstGeom prst="ellipse">
+            <a:avLst/>
+          </a:prstGeom>
+          <a:solidFill>
+            <a:srgbClr val="D92D20"/>
+          </a:solidFill>
+          <a:ln/>
+        </p:spPr>
+      </p:sp>
+      <p:sp>
+        <p:nvSpPr>
+          <p:cNvPr id="6" name="Text 3"/>
+          <p:cNvSpPr/>
+          <p:nvPr/>
+        </p:nvSpPr>
+        <p:spPr>
+          <a:xfrm>
+            <a:off x="8458200" y="1600200"/>
+            <a:ext cx="347472" cy="347472"/>
+          </a:xfrm>
+          <a:prstGeom prst="rect">
+            <a:avLst/>
+          </a:prstGeom>
+          <a:noFill/>
+          <a:ln/>
+        </p:spPr>
+        <p:txBody>
+          <a:bodyPr wrap="square" lIns="0" tIns="0" rIns="0" bIns="0" rtlCol="0" anchor="ctr"/>
+          <a:lstStyle/>
+          <a:p>
+            <a:pPr algn="ctr" indent="0" marL="0">
+              <a:buNone/>
+            </a:pPr>
+            <a:r>
+              <a:rPr lang="en-US" sz="1200" b="1" dirty="0">
+                <a:solidFill>
+                  <a:srgbClr val="FFFFFF"/>
+                </a:solidFill>
+                <a:latin typeface="Calibri" pitchFamily="34" charset="0"/>
+                <a:ea typeface="Calibri" pitchFamily="34" charset="-122"/>
+                <a:cs typeface="Calibri" pitchFamily="34" charset="-120"/>
+              </a:rPr>
+              <a:t>1</a:t>
+            </a:r>
+            <a:endParaRPr lang="en-US" sz="1200" dirty="0"/>
+          </a:p>
+        </p:txBody>
+      </p:sp>
+      <p:sp>
+        <p:nvSpPr>
+          <p:cNvPr id="7" name="Text 4"/>
+          <p:cNvSpPr/>
+          <p:nvPr/>
+        </p:nvSpPr>
+        <p:spPr>
+          <a:xfrm>
+            <a:off x="8942832" y="1563624"/>
+            <a:ext cx="2834640" cy="347472"/>
+          </a:xfrm>
+          <a:prstGeom prst="rect">
+            <a:avLst/>
+          </a:prstGeom>
+          <a:noFill/>
+          <a:ln/>
+        </p:spPr>
+        <p:txBody>
+          <a:bodyPr wrap="square" lIns="0" tIns="0" rIns="0" bIns="0" rtlCol="0" anchor="ctr"/>
+          <a:lstStyle/>
+          <a:p>
+            <a:pPr indent="0" marL="0">
+              <a:buNone/>
+            </a:pPr>
+            <a:r>
+              <a:rPr lang="en-US" sz="1500" b="1" dirty="0">
+                <a:solidFill>
+                  <a:srgbClr val="0B0B0B"/>
+                </a:solidFill>
+                <a:latin typeface="Calibri" pitchFamily="34" charset="0"/>
+                <a:ea typeface="Calibri" pitchFamily="34" charset="-122"/>
+                <a:cs typeface="Calibri" pitchFamily="34" charset="-120"/>
+              </a:rPr>
+              <a:t>Written where the work is</a:t>
+            </a:r>
+            <a:endParaRPr lang="en-US" sz="1500" dirty="0"/>
+          </a:p>
+        </p:txBody>
+      </p:sp>
+      <p:sp>
+        <p:nvSpPr>
+          <p:cNvPr id="8" name="Text 5"/>
+          <p:cNvSpPr/>
+          <p:nvPr/>
+        </p:nvSpPr>
+        <p:spPr>
+          <a:xfrm>
+            <a:off x="8458200" y="1892808"/>
+            <a:ext cx="3291840" cy="960120"/>
+          </a:xfrm>
+          <a:prstGeom prst="rect">
+            <a:avLst/>
+          </a:prstGeom>
+          <a:noFill/>
+          <a:ln/>
+        </p:spPr>
+        <p:txBody>
+          <a:bodyPr wrap="square" lIns="0" tIns="0" rIns="0" bIns="0" rtlCol="0" anchor="ctr"/>
+          <a:lstStyle/>
+          <a:p>
+            <a:pPr indent="0" marL="0">
+              <a:buNone/>
+            </a:pPr>
+            <a:r>
+              <a:rPr lang="en-US" sz="1250" dirty="0">
+                <a:solidFill>
+                  <a:srgbClr val="52514E"/>
+                </a:solidFill>
+                <a:latin typeface="Calibri" pitchFamily="34" charset="0"/>
+                <a:ea typeface="Calibri" pitchFamily="34" charset="-122"/>
+                <a:cs typeface="Calibri" pitchFamily="34" charset="-120"/>
+              </a:rPr>
+              <a:t>Notes are composed on a Pokémon's profile; this page is the cross-collection view of them.</a:t>
+            </a:r>
+            <a:endParaRPr lang="en-US" sz="1250" dirty="0"/>
+          </a:p>
+        </p:txBody>
+      </p:sp>
+      <p:sp>
+        <p:nvSpPr>
+          <p:cNvPr id="9" name="Shape 6"/>
+          <p:cNvSpPr/>
+          <p:nvPr/>
+        </p:nvSpPr>
+        <p:spPr>
+          <a:xfrm>
+            <a:off x="8458200" y="3200400"/>
+            <a:ext cx="347472" cy="347472"/>
+          </a:xfrm>
+          <a:prstGeom prst="ellipse">
+            <a:avLst/>
+          </a:prstGeom>
+          <a:solidFill>
+            <a:srgbClr val="D92D20"/>
+          </a:solidFill>
+          <a:ln/>
+        </p:spPr>
+      </p:sp>
+      <p:sp>
+        <p:nvSpPr>
+          <p:cNvPr id="10" name="Text 7"/>
+          <p:cNvSpPr/>
+          <p:nvPr/>
+        </p:nvSpPr>
+        <p:spPr>
+          <a:xfrm>
+            <a:off x="8458200" y="3200400"/>
+            <a:ext cx="347472" cy="347472"/>
+          </a:xfrm>
+          <a:prstGeom prst="rect">
+            <a:avLst/>
+          </a:prstGeom>
+          <a:noFill/>
+          <a:ln/>
+        </p:spPr>
+        <p:txBody>
+          <a:bodyPr wrap="square" lIns="0" tIns="0" rIns="0" bIns="0" rtlCol="0" anchor="ctr"/>
+          <a:lstStyle/>
+          <a:p>
+            <a:pPr algn="ctr" indent="0" marL="0">
+              <a:buNone/>
+            </a:pPr>
+            <a:r>
+              <a:rPr lang="en-US" sz="1200" b="1" dirty="0">
+                <a:solidFill>
+                  <a:srgbClr val="FFFFFF"/>
+                </a:solidFill>
+                <a:latin typeface="Calibri" pitchFamily="34" charset="0"/>
+                <a:ea typeface="Calibri" pitchFamily="34" charset="-122"/>
+                <a:cs typeface="Calibri" pitchFamily="34" charset="-120"/>
+              </a:rPr>
+              <a:t>2</a:t>
+            </a:r>
+            <a:endParaRPr lang="en-US" sz="1200" dirty="0"/>
+          </a:p>
+        </p:txBody>
+      </p:sp>
+      <p:sp>
+        <p:nvSpPr>
+          <p:cNvPr id="11" name="Text 8"/>
+          <p:cNvSpPr/>
+          <p:nvPr/>
+        </p:nvSpPr>
+        <p:spPr>
+          <a:xfrm>
+            <a:off x="8942832" y="3163824"/>
+            <a:ext cx="2834640" cy="347472"/>
+          </a:xfrm>
+          <a:prstGeom prst="rect">
+            <a:avLst/>
+          </a:prstGeom>
+          <a:noFill/>
+          <a:ln/>
+        </p:spPr>
+        <p:txBody>
+          <a:bodyPr wrap="square" lIns="0" tIns="0" rIns="0" bIns="0" rtlCol="0" anchor="ctr"/>
+          <a:lstStyle/>
+          <a:p>
+            <a:pPr indent="0" marL="0">
+              <a:buNone/>
+            </a:pPr>
+            <a:r>
+              <a:rPr lang="en-US" sz="1500" b="1" dirty="0">
+                <a:solidFill>
+                  <a:srgbClr val="0B0B0B"/>
+                </a:solidFill>
+                <a:latin typeface="Calibri" pitchFamily="34" charset="0"/>
+                <a:ea typeface="Calibri" pitchFamily="34" charset="-122"/>
+                <a:cs typeface="Calibri" pitchFamily="34" charset="-120"/>
+              </a:rPr>
+              <a:t>Attributed to a person</a:t>
+            </a:r>
+            <a:endParaRPr lang="en-US" sz="1500" dirty="0"/>
+          </a:p>
+        </p:txBody>
+      </p:sp>
+      <p:sp>
+        <p:nvSpPr>
+          <p:cNvPr id="12" name="Text 9"/>
+          <p:cNvSpPr/>
+          <p:nvPr/>
+        </p:nvSpPr>
+        <p:spPr>
+          <a:xfrm>
+            <a:off x="8458200" y="3493008"/>
+            <a:ext cx="3291840" cy="960120"/>
+          </a:xfrm>
+          <a:prstGeom prst="rect">
+            <a:avLst/>
+          </a:prstGeom>
+          <a:noFill/>
+          <a:ln/>
+        </p:spPr>
+        <p:txBody>
+          <a:bodyPr wrap="square" lIns="0" tIns="0" rIns="0" bIns="0" rtlCol="0" anchor="ctr"/>
+          <a:lstStyle/>
+          <a:p>
+            <a:pPr indent="0" marL="0">
+              <a:buNone/>
+            </a:pPr>
+            <a:r>
+              <a:rPr lang="en-US" sz="1250" dirty="0">
+                <a:solidFill>
+                  <a:srgbClr val="52514E"/>
+                </a:solidFill>
+                <a:latin typeface="Calibri" pitchFamily="34" charset="0"/>
+                <a:ea typeface="Calibri" pitchFamily="34" charset="-122"/>
+                <a:cs typeface="Calibri" pitchFamily="34" charset="-120"/>
+              </a:rPr>
+              <a:t>Every note carries its author, and “only mine” narrows the feed to whoever the app is acting as.</a:t>
+            </a:r>
+            <a:endParaRPr lang="en-US" sz="1250" dirty="0"/>
+          </a:p>
+        </p:txBody>
+      </p:sp>
+      <p:sp>
+        <p:nvSpPr>
+          <p:cNvPr id="13" name="Shape 10"/>
+          <p:cNvSpPr/>
+          <p:nvPr/>
+        </p:nvSpPr>
+        <p:spPr>
+          <a:xfrm>
+            <a:off x="8458200" y="4800600"/>
+            <a:ext cx="347472" cy="347472"/>
+          </a:xfrm>
+          <a:prstGeom prst="ellipse">
+            <a:avLst/>
+          </a:prstGeom>
+          <a:solidFill>
+            <a:srgbClr val="D92D20"/>
+          </a:solidFill>
+          <a:ln/>
+        </p:spPr>
+      </p:sp>
+      <p:sp>
+        <p:nvSpPr>
+          <p:cNvPr id="14" name="Text 11"/>
+          <p:cNvSpPr/>
+          <p:nvPr/>
+        </p:nvSpPr>
+        <p:spPr>
+          <a:xfrm>
+            <a:off x="8458200" y="4800600"/>
+            <a:ext cx="347472" cy="347472"/>
+          </a:xfrm>
+          <a:prstGeom prst="rect">
+            <a:avLst/>
+          </a:prstGeom>
+          <a:noFill/>
+          <a:ln/>
+        </p:spPr>
+        <p:txBody>
+          <a:bodyPr wrap="square" lIns="0" tIns="0" rIns="0" bIns="0" rtlCol="0" anchor="ctr"/>
+          <a:lstStyle/>
+          <a:p>
+            <a:pPr algn="ctr" indent="0" marL="0">
+              <a:buNone/>
+            </a:pPr>
+            <a:r>
+              <a:rPr lang="en-US" sz="1200" b="1" dirty="0">
+                <a:solidFill>
+                  <a:srgbClr val="FFFFFF"/>
+                </a:solidFill>
+                <a:latin typeface="Calibri" pitchFamily="34" charset="0"/>
+                <a:ea typeface="Calibri" pitchFamily="34" charset="-122"/>
+                <a:cs typeface="Calibri" pitchFamily="34" charset="-120"/>
+              </a:rPr>
+              <a:t>3</a:t>
+            </a:r>
+            <a:endParaRPr lang="en-US" sz="1200" dirty="0"/>
+          </a:p>
+        </p:txBody>
+      </p:sp>
+      <p:sp>
+        <p:nvSpPr>
+          <p:cNvPr id="15" name="Text 12"/>
+          <p:cNvSpPr/>
+          <p:nvPr/>
+        </p:nvSpPr>
+        <p:spPr>
+          <a:xfrm>
+            <a:off x="8942832" y="4764024"/>
+            <a:ext cx="2834640" cy="347472"/>
+          </a:xfrm>
+          <a:prstGeom prst="rect">
+            <a:avLst/>
+          </a:prstGeom>
+          <a:noFill/>
+          <a:ln/>
+        </p:spPr>
+        <p:txBody>
+          <a:bodyPr wrap="square" lIns="0" tIns="0" rIns="0" bIns="0" rtlCol="0" anchor="ctr"/>
+          <a:lstStyle/>
+          <a:p>
+            <a:pPr indent="0" marL="0">
+              <a:buNone/>
+            </a:pPr>
+            <a:r>
+              <a:rPr lang="en-US" sz="1500" b="1" dirty="0">
+                <a:solidFill>
+                  <a:srgbClr val="0B0B0B"/>
+                </a:solidFill>
+                <a:latin typeface="Calibri" pitchFamily="34" charset="0"/>
+                <a:ea typeface="Calibri" pitchFamily="34" charset="-122"/>
+                <a:cs typeface="Calibri" pitchFamily="34" charset="-120"/>
+              </a:rPr>
+              <a:t>Scoped by trainer</a:t>
+            </a:r>
+            <a:endParaRPr lang="en-US" sz="1500" dirty="0"/>
+          </a:p>
+        </p:txBody>
+      </p:sp>
+      <p:sp>
+        <p:nvSpPr>
+          <p:cNvPr id="16" name="Text 13"/>
+          <p:cNvSpPr/>
+          <p:nvPr/>
+        </p:nvSpPr>
+        <p:spPr>
+          <a:xfrm>
+            <a:off x="8458200" y="5093208"/>
+            <a:ext cx="3291840" cy="960120"/>
+          </a:xfrm>
+          <a:prstGeom prst="rect">
+            <a:avLst/>
+          </a:prstGeom>
+          <a:noFill/>
+          <a:ln/>
+        </p:spPr>
+        <p:txBody>
+          <a:bodyPr wrap="square" lIns="0" tIns="0" rIns="0" bIns="0" rtlCol="0" anchor="ctr"/>
+          <a:lstStyle/>
+          <a:p>
+            <a:pPr indent="0" marL="0">
+              <a:buNone/>
+            </a:pPr>
+            <a:r>
+              <a:rPr lang="en-US" sz="1250" dirty="0">
+                <a:solidFill>
+                  <a:srgbClr val="52514E"/>
+                </a:solidFill>
+                <a:latin typeface="Calibri" pitchFamily="34" charset="0"/>
+                <a:ea typeface="Calibri" pitchFamily="34" charset="-122"/>
+                <a:cs typeface="Calibri" pitchFamily="34" charset="-120"/>
+              </a:rPr>
+              <a:t>There is no trainer column — the filter joins through the roster, so a caseload's history is derived, not duplicated.</a:t>
+            </a:r>
+            <a:endParaRPr lang="en-US" sz="1250" dirty="0"/>
+          </a:p>
+        </p:txBody>
+      </p:sp>
+    </p:spTree>
+  </p:cSld>
+  <p:clrMapOvr>
+    <a:masterClrMapping/>
+  </p:clrMapOvr>
+</p:sld>
+</file>
+
+<file path=ppt/slides/slide15.xml><?xml version="1.0" encoding="utf-8"?>
+<p:sld xmlns:a="http://schemas.openxmlformats.org/drawingml/2006/main" xmlns:r="http://schemas.openxmlformats.org/officeDocument/2006/relationships" xmlns:p="http://schemas.openxmlformats.org/presentationml/2006/main">
+  <p:cSld name="Slide 3">
+    <p:bg>
+      <p:bgPr>
+        <a:solidFill>
+          <a:srgbClr val="FFFFFF"/>
+        </a:solidFill>
+      </p:bgPr>
+    </p:bg>
+    <p:spTree>
+      <p:nvGrpSpPr>
+        <p:cNvPr id="1" name=""/>
+        <p:cNvGrpSpPr/>
+        <p:nvPr/>
+      </p:nvGrpSpPr>
+      <p:grpSpPr>
+        <a:xfrm>
+          <a:off x="0" y="0"/>
+          <a:ext cx="0" cy="0"/>
+          <a:chOff x="0" y="0"/>
+          <a:chExt cx="0" cy="0"/>
+        </a:xfrm>
+      </p:grpSpPr>
+      <p:sp>
+        <p:nvSpPr>
+          <p:cNvPr id="2" name="Text 0"/>
+          <p:cNvSpPr/>
+          <p:nvPr/>
+        </p:nvSpPr>
+        <p:spPr>
+          <a:xfrm>
+            <a:off x="548640" y="384048"/>
+            <a:ext cx="7863840" cy="566928"/>
+          </a:xfrm>
+          <a:prstGeom prst="rect">
+            <a:avLst/>
+          </a:prstGeom>
+          <a:noFill/>
+          <a:ln/>
+        </p:spPr>
+        <p:txBody>
+          <a:bodyPr wrap="square" lIns="0" tIns="0" rIns="0" bIns="0" rtlCol="0" anchor="ctr"/>
+          <a:lstStyle/>
+          <a:p>
+            <a:pPr indent="0" marL="0">
+              <a:buNone/>
+            </a:pPr>
+            <a:r>
+              <a:rPr lang="en-US" sz="3000" b="1" dirty="0">
+                <a:solidFill>
+                  <a:srgbClr val="0B0B0B"/>
+                </a:solidFill>
+                <a:latin typeface="Cambria" pitchFamily="34" charset="0"/>
+                <a:ea typeface="Cambria" pitchFamily="34" charset="-122"/>
+                <a:cs typeface="Cambria" pitchFamily="34" charset="-120"/>
+              </a:rPr>
+              <a:t>Activity — one table, three views</a:t>
+            </a:r>
+            <a:endParaRPr lang="en-US" sz="3000" dirty="0"/>
+          </a:p>
+        </p:txBody>
+      </p:sp>
+      <p:sp>
+        <p:nvSpPr>
+          <p:cNvPr id="3" name="Text 1"/>
+          <p:cNvSpPr/>
+          <p:nvPr/>
+        </p:nvSpPr>
+        <p:spPr>
+          <a:xfrm>
+            <a:off x="548640" y="950976"/>
+            <a:ext cx="8778240" cy="365760"/>
+          </a:xfrm>
+          <a:prstGeom prst="rect">
+            <a:avLst/>
+          </a:prstGeom>
+          <a:noFill/>
+          <a:ln/>
+        </p:spPr>
+        <p:txBody>
+          <a:bodyPr wrap="square" lIns="0" tIns="0" rIns="0" bIns="0" rtlCol="0" anchor="ctr"/>
+          <a:lstStyle/>
+          <a:p>
+            <a:pPr indent="0" marL="0">
+              <a:buNone/>
+            </a:pPr>
+            <a:r>
+              <a:rPr lang="en-US" sz="1400" dirty="0">
+                <a:solidFill>
+                  <a:srgbClr val="52514E"/>
+                </a:solidFill>
+                <a:latin typeface="Calibri" pitchFamily="34" charset="0"/>
+                <a:ea typeface="Calibri" pitchFamily="34" charset="-122"/>
+                <a:cs typeface="Calibri" pitchFamily="34" charset="-120"/>
+              </a:rPr>
+              <a:t>Caught, favorite, wishlist, flagged, reviewed — toggled on a profile, audited here.</a:t>
+            </a:r>
+            <a:endParaRPr lang="en-US" sz="1400" dirty="0"/>
+          </a:p>
+        </p:txBody>
+      </p:sp>
+      <p:pic>
+        <p:nvPicPr>
+          <p:cNvPr id="4" name="Image 0" descr="preencoded.png">    </p:cNvPr>
+          <p:cNvPicPr>
+            <a:picLocks noChangeAspect="1"/>
+          </p:cNvPicPr>
+          <p:nvPr/>
+        </p:nvPicPr>
+        <p:blipFill>
+          <a:blip r:embed="rId1"/>
+          <a:stretch>
+            <a:fillRect/>
+          </a:stretch>
+        </p:blipFill>
+        <p:spPr>
+          <a:xfrm>
+            <a:off x="957507" y="1463040"/>
+            <a:ext cx="6771785" cy="4937760"/>
+          </a:xfrm>
+          <a:prstGeom prst="rect">
+            <a:avLst/>
+          </a:prstGeom>
+          <a:effectLst>
+            <a:outerShdw sx="100000" sy="100000" kx="0" ky="0" algn="bl" rotWithShape="0" blurRad="177800" dist="38100" dir="5400000">
+              <a:srgbClr val="000000">
+                <a:alpha val="18000"/>
+              </a:srgbClr>
+            </a:outerShdw>
+          </a:effectLst>
+        </p:spPr>
+      </p:pic>
+      <p:sp>
+        <p:nvSpPr>
+          <p:cNvPr id="5" name="Shape 2"/>
+          <p:cNvSpPr/>
+          <p:nvPr/>
+        </p:nvSpPr>
+        <p:spPr>
+          <a:xfrm>
+            <a:off x="8458200" y="1600200"/>
+            <a:ext cx="347472" cy="347472"/>
+          </a:xfrm>
+          <a:prstGeom prst="ellipse">
+            <a:avLst/>
+          </a:prstGeom>
+          <a:solidFill>
+            <a:srgbClr val="D92D20"/>
+          </a:solidFill>
+          <a:ln/>
+        </p:spPr>
+      </p:sp>
+      <p:sp>
+        <p:nvSpPr>
+          <p:cNvPr id="6" name="Text 3"/>
+          <p:cNvSpPr/>
+          <p:nvPr/>
+        </p:nvSpPr>
+        <p:spPr>
+          <a:xfrm>
+            <a:off x="8458200" y="1600200"/>
+            <a:ext cx="347472" cy="347472"/>
+          </a:xfrm>
+          <a:prstGeom prst="rect">
+            <a:avLst/>
+          </a:prstGeom>
+          <a:noFill/>
+          <a:ln/>
+        </p:spPr>
+        <p:txBody>
+          <a:bodyPr wrap="square" lIns="0" tIns="0" rIns="0" bIns="0" rtlCol="0" anchor="ctr"/>
+          <a:lstStyle/>
+          <a:p>
+            <a:pPr algn="ctr" indent="0" marL="0">
+              <a:buNone/>
+            </a:pPr>
+            <a:r>
+              <a:rPr lang="en-US" sz="1200" b="1" dirty="0">
+                <a:solidFill>
+                  <a:srgbClr val="FFFFFF"/>
+                </a:solidFill>
+                <a:latin typeface="Calibri" pitchFamily="34" charset="0"/>
+                <a:ea typeface="Calibri" pitchFamily="34" charset="-122"/>
+                <a:cs typeface="Calibri" pitchFamily="34" charset="-120"/>
+              </a:rPr>
+              <a:t>1</a:t>
+            </a:r>
+            <a:endParaRPr lang="en-US" sz="1200" dirty="0"/>
+          </a:p>
+        </p:txBody>
+      </p:sp>
+      <p:sp>
+        <p:nvSpPr>
+          <p:cNvPr id="7" name="Text 4"/>
+          <p:cNvSpPr/>
+          <p:nvPr/>
+        </p:nvSpPr>
+        <p:spPr>
+          <a:xfrm>
+            <a:off x="8942832" y="1563624"/>
+            <a:ext cx="2834640" cy="347472"/>
+          </a:xfrm>
+          <a:prstGeom prst="rect">
+            <a:avLst/>
+          </a:prstGeom>
+          <a:noFill/>
+          <a:ln/>
+        </p:spPr>
+        <p:txBody>
+          <a:bodyPr wrap="square" lIns="0" tIns="0" rIns="0" bIns="0" rtlCol="0" anchor="ctr"/>
+          <a:lstStyle/>
+          <a:p>
+            <a:pPr indent="0" marL="0">
+              <a:buNone/>
+            </a:pPr>
+            <a:r>
+              <a:rPr lang="en-US" sz="1500" b="1" dirty="0">
+                <a:solidFill>
+                  <a:srgbClr val="0B0B0B"/>
+                </a:solidFill>
+                <a:latin typeface="Calibri" pitchFamily="34" charset="0"/>
+                <a:ea typeface="Calibri" pitchFamily="34" charset="-122"/>
+                <a:cs typeface="Calibri" pitchFamily="34" charset="-120"/>
+              </a:rPr>
+              <a:t>Toggles are the trail</a:t>
+            </a:r>
+            <a:endParaRPr lang="en-US" sz="1500" dirty="0"/>
+          </a:p>
+        </p:txBody>
+      </p:sp>
+      <p:sp>
+        <p:nvSpPr>
+          <p:cNvPr id="8" name="Text 5"/>
+          <p:cNvSpPr/>
+          <p:nvPr/>
+        </p:nvSpPr>
+        <p:spPr>
+          <a:xfrm>
+            <a:off x="8458200" y="1892808"/>
+            <a:ext cx="3291840" cy="960120"/>
+          </a:xfrm>
+          <a:prstGeom prst="rect">
+            <a:avLst/>
+          </a:prstGeom>
+          <a:noFill/>
+          <a:ln/>
+        </p:spPr>
+        <p:txBody>
+          <a:bodyPr wrap="square" lIns="0" tIns="0" rIns="0" bIns="0" rtlCol="0" anchor="ctr"/>
+          <a:lstStyle/>
+          <a:p>
+            <a:pPr indent="0" marL="0">
+              <a:buNone/>
+            </a:pPr>
+            <a:r>
+              <a:rPr lang="en-US" sz="1250" dirty="0">
+                <a:solidFill>
+                  <a:srgbClr val="52514E"/>
+                </a:solidFill>
+                <a:latin typeface="Calibri" pitchFamily="34" charset="0"/>
+                <a:ea typeface="Calibri" pitchFamily="34" charset="-122"/>
+                <a:cs typeface="Calibri" pitchFamily="34" charset="-120"/>
+              </a:rPr>
+              <a:t>Setting a flag inserts a row and clearing it deletes one, so removing a log entry is clearing the flag.</a:t>
+            </a:r>
+            <a:endParaRPr lang="en-US" sz="1250" dirty="0"/>
+          </a:p>
+        </p:txBody>
+      </p:sp>
+      <p:sp>
+        <p:nvSpPr>
+          <p:cNvPr id="9" name="Shape 6"/>
+          <p:cNvSpPr/>
+          <p:nvPr/>
+        </p:nvSpPr>
+        <p:spPr>
+          <a:xfrm>
+            <a:off x="8458200" y="3200400"/>
+            <a:ext cx="347472" cy="347472"/>
+          </a:xfrm>
+          <a:prstGeom prst="ellipse">
+            <a:avLst/>
+          </a:prstGeom>
+          <a:solidFill>
+            <a:srgbClr val="D92D20"/>
+          </a:solidFill>
+          <a:ln/>
+        </p:spPr>
+      </p:sp>
+      <p:sp>
+        <p:nvSpPr>
+          <p:cNvPr id="10" name="Text 7"/>
+          <p:cNvSpPr/>
+          <p:nvPr/>
+        </p:nvSpPr>
+        <p:spPr>
+          <a:xfrm>
+            <a:off x="8458200" y="3200400"/>
+            <a:ext cx="347472" cy="347472"/>
+          </a:xfrm>
+          <a:prstGeom prst="rect">
+            <a:avLst/>
+          </a:prstGeom>
+          <a:noFill/>
+          <a:ln/>
+        </p:spPr>
+        <p:txBody>
+          <a:bodyPr wrap="square" lIns="0" tIns="0" rIns="0" bIns="0" rtlCol="0" anchor="ctr"/>
+          <a:lstStyle/>
+          <a:p>
+            <a:pPr algn="ctr" indent="0" marL="0">
+              <a:buNone/>
+            </a:pPr>
+            <a:r>
+              <a:rPr lang="en-US" sz="1200" b="1" dirty="0">
+                <a:solidFill>
+                  <a:srgbClr val="FFFFFF"/>
+                </a:solidFill>
+                <a:latin typeface="Calibri" pitchFamily="34" charset="0"/>
+                <a:ea typeface="Calibri" pitchFamily="34" charset="-122"/>
+                <a:cs typeface="Calibri" pitchFamily="34" charset="-120"/>
+              </a:rPr>
+              <a:t>2</a:t>
+            </a:r>
+            <a:endParaRPr lang="en-US" sz="1200" dirty="0"/>
+          </a:p>
+        </p:txBody>
+      </p:sp>
+      <p:sp>
+        <p:nvSpPr>
+          <p:cNvPr id="11" name="Text 8"/>
+          <p:cNvSpPr/>
+          <p:nvPr/>
+        </p:nvSpPr>
+        <p:spPr>
+          <a:xfrm>
+            <a:off x="8942832" y="3163824"/>
+            <a:ext cx="2834640" cy="347472"/>
+          </a:xfrm>
+          <a:prstGeom prst="rect">
+            <a:avLst/>
+          </a:prstGeom>
+          <a:noFill/>
+          <a:ln/>
+        </p:spPr>
+        <p:txBody>
+          <a:bodyPr wrap="square" lIns="0" tIns="0" rIns="0" bIns="0" rtlCol="0" anchor="ctr"/>
+          <a:lstStyle/>
+          <a:p>
+            <a:pPr indent="0" marL="0">
+              <a:buNone/>
+            </a:pPr>
+            <a:r>
+              <a:rPr lang="en-US" sz="1500" b="1" dirty="0">
+                <a:solidFill>
+                  <a:srgbClr val="0B0B0B"/>
+                </a:solidFill>
+                <a:latin typeface="Calibri" pitchFamily="34" charset="0"/>
+                <a:ea typeface="Calibri" pitchFamily="34" charset="-122"/>
+                <a:cs typeface="Calibri" pitchFamily="34" charset="-120"/>
+              </a:rPr>
+              <a:t>Reviewed is the exception</a:t>
+            </a:r>
+            <a:endParaRPr lang="en-US" sz="1500" dirty="0"/>
+          </a:p>
+        </p:txBody>
+      </p:sp>
+      <p:sp>
+        <p:nvSpPr>
+          <p:cNvPr id="12" name="Text 9"/>
+          <p:cNvSpPr/>
+          <p:nvPr/>
+        </p:nvSpPr>
+        <p:spPr>
+          <a:xfrm>
+            <a:off x="8458200" y="3493008"/>
+            <a:ext cx="3291840" cy="960120"/>
+          </a:xfrm>
+          <a:prstGeom prst="rect">
+            <a:avLst/>
+          </a:prstGeom>
+          <a:noFill/>
+          <a:ln/>
+        </p:spPr>
+        <p:txBody>
+          <a:bodyPr wrap="square" lIns="0" tIns="0" rIns="0" bIns="0" rtlCol="0" anchor="ctr"/>
+          <a:lstStyle/>
+          <a:p>
+            <a:pPr indent="0" marL="0">
+              <a:buNone/>
+            </a:pPr>
+            <a:r>
+              <a:rPr lang="en-US" sz="1250" dirty="0">
+                <a:solidFill>
+                  <a:srgbClr val="52514E"/>
+                </a:solidFill>
+                <a:latin typeface="Calibri" pitchFamily="34" charset="0"/>
+                <a:ea typeface="Calibri" pitchFamily="34" charset="-122"/>
+                <a:cs typeface="Calibri" pitchFamily="34" charset="-120"/>
+              </a:rPr>
+              <a:t>Re-posting it bumps the timestamp instead of clearing it — which is what the stale-review signal reads.</a:t>
+            </a:r>
+            <a:endParaRPr lang="en-US" sz="1250" dirty="0"/>
+          </a:p>
+        </p:txBody>
+      </p:sp>
+      <p:sp>
+        <p:nvSpPr>
+          <p:cNvPr id="13" name="Shape 10"/>
+          <p:cNvSpPr/>
+          <p:nvPr/>
+        </p:nvSpPr>
+        <p:spPr>
+          <a:xfrm>
+            <a:off x="8458200" y="4800600"/>
+            <a:ext cx="347472" cy="347472"/>
+          </a:xfrm>
+          <a:prstGeom prst="ellipse">
+            <a:avLst/>
+          </a:prstGeom>
+          <a:solidFill>
+            <a:srgbClr val="D92D20"/>
+          </a:solidFill>
+          <a:ln/>
+        </p:spPr>
+      </p:sp>
+      <p:sp>
+        <p:nvSpPr>
+          <p:cNvPr id="14" name="Text 11"/>
+          <p:cNvSpPr/>
+          <p:nvPr/>
+        </p:nvSpPr>
+        <p:spPr>
+          <a:xfrm>
+            <a:off x="8458200" y="4800600"/>
+            <a:ext cx="347472" cy="347472"/>
+          </a:xfrm>
+          <a:prstGeom prst="rect">
+            <a:avLst/>
+          </a:prstGeom>
+          <a:noFill/>
+          <a:ln/>
+        </p:spPr>
+        <p:txBody>
+          <a:bodyPr wrap="square" lIns="0" tIns="0" rIns="0" bIns="0" rtlCol="0" anchor="ctr"/>
+          <a:lstStyle/>
+          <a:p>
+            <a:pPr algn="ctr" indent="0" marL="0">
+              <a:buNone/>
+            </a:pPr>
+            <a:r>
+              <a:rPr lang="en-US" sz="1200" b="1" dirty="0">
+                <a:solidFill>
+                  <a:srgbClr val="FFFFFF"/>
+                </a:solidFill>
+                <a:latin typeface="Calibri" pitchFamily="34" charset="0"/>
+                <a:ea typeface="Calibri" pitchFamily="34" charset="-122"/>
+                <a:cs typeface="Calibri" pitchFamily="34" charset="-120"/>
+              </a:rPr>
+              <a:t>3</a:t>
+            </a:r>
+            <a:endParaRPr lang="en-US" sz="1200" dirty="0"/>
+          </a:p>
+        </p:txBody>
+      </p:sp>
+      <p:sp>
+        <p:nvSpPr>
+          <p:cNvPr id="15" name="Text 12"/>
+          <p:cNvSpPr/>
+          <p:nvPr/>
+        </p:nvSpPr>
+        <p:spPr>
+          <a:xfrm>
+            <a:off x="8942832" y="4764024"/>
+            <a:ext cx="2834640" cy="347472"/>
+          </a:xfrm>
+          <a:prstGeom prst="rect">
+            <a:avLst/>
+          </a:prstGeom>
+          <a:noFill/>
+          <a:ln/>
+        </p:spPr>
+        <p:txBody>
+          <a:bodyPr wrap="square" lIns="0" tIns="0" rIns="0" bIns="0" rtlCol="0" anchor="ctr"/>
+          <a:lstStyle/>
+          <a:p>
+            <a:pPr indent="0" marL="0">
+              <a:buNone/>
+            </a:pPr>
+            <a:r>
+              <a:rPr lang="en-US" sz="1500" b="1" dirty="0">
+                <a:solidFill>
+                  <a:srgbClr val="0B0B0B"/>
+                </a:solidFill>
+                <a:latin typeface="Calibri" pitchFamily="34" charset="0"/>
+                <a:ea typeface="Calibri" pitchFamily="34" charset="-122"/>
+                <a:cs typeface="Calibri" pitchFamily="34" charset="-120"/>
+              </a:rPr>
+              <a:t>Tiles stay put</a:t>
+            </a:r>
+            <a:endParaRPr lang="en-US" sz="1500" dirty="0"/>
+          </a:p>
+        </p:txBody>
+      </p:sp>
+      <p:sp>
+        <p:nvSpPr>
+          <p:cNvPr id="16" name="Text 13"/>
+          <p:cNvSpPr/>
+          <p:nvPr/>
+        </p:nvSpPr>
+        <p:spPr>
+          <a:xfrm>
+            <a:off x="8458200" y="5093208"/>
+            <a:ext cx="3291840" cy="960120"/>
+          </a:xfrm>
+          <a:prstGeom prst="rect">
+            <a:avLst/>
+          </a:prstGeom>
+          <a:noFill/>
+          <a:ln/>
+        </p:spPr>
+        <p:txBody>
+          <a:bodyPr wrap="square" lIns="0" tIns="0" rIns="0" bIns="0" rtlCol="0" anchor="ctr"/>
+          <a:lstStyle/>
+          <a:p>
+            <a:pPr indent="0" marL="0">
+              <a:buNone/>
+            </a:pPr>
+            <a:r>
+              <a:rPr lang="en-US" sz="1250" dirty="0">
+                <a:solidFill>
+                  <a:srgbClr val="52514E"/>
+                </a:solidFill>
+                <a:latin typeface="Calibri" pitchFamily="34" charset="0"/>
+                <a:ea typeface="Calibri" pitchFamily="34" charset="-122"/>
+                <a:cs typeface="Calibri" pitchFamily="34" charset="-120"/>
+              </a:rPr>
+              <a:t>The summary counts are deliberately unfiltered, so they don't shift while you filter the table beneath them.</a:t>
+            </a:r>
+            <a:endParaRPr lang="en-US" sz="1250" dirty="0"/>
+          </a:p>
+        </p:txBody>
+      </p:sp>
+    </p:spTree>
+  </p:cSld>
+  <p:clrMapOvr>
+    <a:masterClrMapping/>
+  </p:clrMapOvr>
+</p:sld>
+</file>
+
+<file path=ppt/slides/slide16.xml><?xml version="1.0" encoding="utf-8"?>
+<p:sld xmlns:a="http://schemas.openxmlformats.org/drawingml/2006/main" xmlns:r="http://schemas.openxmlformats.org/officeDocument/2006/relationships" xmlns:p="http://schemas.openxmlformats.org/presentationml/2006/main">
+  <p:cSld name="Slide 9">
+    <p:bg>
+      <p:bgPr>
+        <a:solidFill>
+          <a:srgbClr val="F4F4F2"/>
+        </a:solidFill>
+      </p:bgPr>
+    </p:bg>
+    <p:spTree>
+      <p:nvGrpSpPr>
+        <p:cNvPr id="1" name=""/>
+        <p:cNvGrpSpPr/>
+        <p:nvPr/>
+      </p:nvGrpSpPr>
+      <p:grpSpPr>
+        <a:xfrm>
+          <a:off x="0" y="0"/>
+          <a:ext cx="0" cy="0"/>
+          <a:chOff x="0" y="0"/>
+          <a:chExt cx="0" cy="0"/>
+        </a:xfrm>
+      </p:grpSpPr>
+      <p:sp>
+        <p:nvSpPr>
+          <p:cNvPr id="2" name="Text 0"/>
+          <p:cNvSpPr/>
+          <p:nvPr/>
+        </p:nvSpPr>
+        <p:spPr>
+          <a:xfrm>
+            <a:off x="548640" y="384048"/>
+            <a:ext cx="7863840" cy="566928"/>
+          </a:xfrm>
+          <a:prstGeom prst="rect">
+            <a:avLst/>
+          </a:prstGeom>
+          <a:noFill/>
+          <a:ln/>
+        </p:spPr>
+        <p:txBody>
+          <a:bodyPr wrap="square" lIns="0" tIns="0" rIns="0" bIns="0" rtlCol="0" anchor="ctr"/>
+          <a:lstStyle/>
+          <a:p>
+            <a:pPr indent="0" marL="0">
+              <a:buNone/>
+            </a:pPr>
+            <a:r>
+              <a:rPr lang="en-US" sz="3000" b="1" dirty="0">
+                <a:solidFill>
+                  <a:srgbClr val="0B0B0B"/>
+                </a:solidFill>
+                <a:latin typeface="Cambria" pitchFamily="34" charset="0"/>
+                <a:ea typeface="Cambria" pitchFamily="34" charset="-122"/>
+                <a:cs typeface="Cambria" pitchFamily="34" charset="-120"/>
+              </a:rPr>
+              <a:t>Tableau — the same story, elsewhere</a:t>
+            </a:r>
+            <a:endParaRPr lang="en-US" sz="3000" dirty="0"/>
+          </a:p>
+        </p:txBody>
+      </p:sp>
+      <p:sp>
+        <p:nvSpPr>
+          <p:cNvPr id="3" name="Text 1"/>
+          <p:cNvSpPr/>
+          <p:nvPr/>
+        </p:nvSpPr>
+        <p:spPr>
+          <a:xfrm>
+            <a:off x="548640" y="950976"/>
+            <a:ext cx="8778240" cy="365760"/>
+          </a:xfrm>
+          <a:prstGeom prst="rect">
+            <a:avLst/>
+          </a:prstGeom>
+          <a:noFill/>
+          <a:ln/>
+        </p:spPr>
+        <p:txBody>
+          <a:bodyPr wrap="square" lIns="0" tIns="0" rIns="0" bIns="0" rtlCol="0" anchor="ctr"/>
+          <a:lstStyle/>
+          <a:p>
+            <a:pPr indent="0" marL="0">
+              <a:buNone/>
+            </a:pPr>
+            <a:r>
+              <a:rPr lang="en-US" sz="1400" dirty="0">
+                <a:solidFill>
+                  <a:srgbClr val="52514E"/>
+                </a:solidFill>
+                <a:latin typeface="Calibri" pitchFamily="34" charset="0"/>
+                <a:ea typeface="Calibri" pitchFamily="34" charset="-122"/>
+                <a:cs typeface="Calibri" pitchFamily="34" charset="-120"/>
+              </a:rPr>
+              <a:t>A published Tableau Public workbook, embedded beside the app's own charts.</a:t>
+            </a:r>
+            <a:endParaRPr lang="en-US" sz="1400" dirty="0"/>
+          </a:p>
+        </p:txBody>
+      </p:sp>
+      <p:pic>
+        <p:nvPicPr>
+          <p:cNvPr id="4" name="Image 0" descr="preencoded.png">    </p:cNvPr>
+          <p:cNvPicPr>
+            <a:picLocks noChangeAspect="1"/>
+          </p:cNvPicPr>
+          <p:nvPr/>
+        </p:nvPicPr>
+        <p:blipFill>
+          <a:blip r:embed="rId1"/>
+          <a:stretch>
+            <a:fillRect/>
+          </a:stretch>
+        </p:blipFill>
+        <p:spPr>
+          <a:xfrm>
+            <a:off x="3008376" y="1536192"/>
+            <a:ext cx="6144768" cy="4480560"/>
+          </a:xfrm>
+          <a:prstGeom prst="rect">
+            <a:avLst/>
+          </a:prstGeom>
+          <a:effectLst>
+            <a:outerShdw sx="100000" sy="100000" kx="0" ky="0" algn="bl" rotWithShape="0" blurRad="177800" dist="38100" dir="5400000">
+              <a:srgbClr val="000000">
+                <a:alpha val="18000"/>
+              </a:srgbClr>
+            </a:outerShdw>
+          </a:effectLst>
+        </p:spPr>
+      </p:pic>
+      <p:sp>
+        <p:nvSpPr>
+          <p:cNvPr id="5" name="Text 2"/>
+          <p:cNvSpPr/>
+          <p:nvPr/>
+        </p:nvSpPr>
+        <p:spPr>
+          <a:xfrm>
+            <a:off x="548640" y="6144768"/>
+            <a:ext cx="11064240" cy="365760"/>
+          </a:xfrm>
+          <a:prstGeom prst="rect">
+            <a:avLst/>
+          </a:prstGeom>
+          <a:noFill/>
+          <a:ln/>
+        </p:spPr>
+        <p:txBody>
+          <a:bodyPr wrap="square" lIns="0" tIns="0" rIns="0" bIns="0" rtlCol="0" anchor="ctr"/>
+          <a:lstStyle/>
+          <a:p>
+            <a:pPr indent="0" marL="0">
+              <a:buNone/>
+            </a:pPr>
+            <a:r>
+              <a:rPr lang="en-US" sz="1200" dirty="0">
+                <a:solidFill>
+                  <a:srgbClr val="52514E"/>
+                </a:solidFill>
+                <a:latin typeface="Calibri" pitchFamily="34" charset="0"/>
+                <a:ea typeface="Calibri" pitchFamily="34" charset="-122"/>
+                <a:cs typeface="Calibri" pitchFamily="34" charset="-120"/>
+              </a:rPr>
+              <a:t>Embedding API v3, with the viz element created imperatively so React never owns it — and the one page in the app not backed by the CRM database.</a:t>
+            </a:r>
+            <a:endParaRPr lang="en-US" sz="1200" dirty="0"/>
           </a:p>
         </p:txBody>
       </p:sp>
@@ -4371,8 +7204,8 @@
         </p:blipFill>
         <p:spPr>
           <a:xfrm>
-            <a:off x="548640" y="1463040"/>
-            <a:ext cx="7589520" cy="4937760"/>
+            <a:off x="957507" y="1463040"/>
+            <a:ext cx="6771785" cy="4937760"/>
           </a:xfrm>
           <a:prstGeom prst="rect">
             <a:avLst/>
@@ -5643,8 +8476,8 @@
         </p:blipFill>
         <p:spPr>
           <a:xfrm>
-            <a:off x="8001000" y="1691640"/>
-            <a:ext cx="3703320" cy="2697480"/>
+            <a:off x="8001000" y="1798572"/>
+            <a:ext cx="3703320" cy="2483616"/>
           </a:xfrm>
           <a:prstGeom prst="rect">
             <a:avLst/>
@@ -5884,8 +8717,8 @@
         </p:blipFill>
         <p:spPr>
           <a:xfrm>
-            <a:off x="548640" y="1463040"/>
-            <a:ext cx="7589520" cy="4937760"/>
+            <a:off x="957507" y="1463040"/>
+            <a:ext cx="6771785" cy="4937760"/>
           </a:xfrm>
           <a:prstGeom prst="rect">
             <a:avLst/>
@@ -6436,8 +9269,8 @@
         </p:blipFill>
         <p:spPr>
           <a:xfrm>
-            <a:off x="548640" y="1536192"/>
-            <a:ext cx="11064240" cy="4480560"/>
+            <a:off x="2740280" y="1536192"/>
+            <a:ext cx="6680960" cy="4480560"/>
           </a:xfrm>
           <a:prstGeom prst="rect">
             <a:avLst/>
@@ -6616,8 +9449,8 @@
         </p:blipFill>
         <p:spPr>
           <a:xfrm>
-            <a:off x="548640" y="1536192"/>
-            <a:ext cx="11064240" cy="4160520"/>
+            <a:off x="2978885" y="1536192"/>
+            <a:ext cx="6203749" cy="4160520"/>
           </a:xfrm>
           <a:prstGeom prst="rect">
             <a:avLst/>
@@ -7001,8 +9834,8 @@
         </p:blipFill>
         <p:spPr>
           <a:xfrm>
-            <a:off x="548640" y="1463040"/>
-            <a:ext cx="7589520" cy="4937760"/>
+            <a:off x="662054" y="1463040"/>
+            <a:ext cx="7362691" cy="4937760"/>
           </a:xfrm>
           <a:prstGeom prst="rect">
             <a:avLst/>
@@ -7553,8 +10386,8 @@
         </p:blipFill>
         <p:spPr>
           <a:xfrm>
-            <a:off x="548640" y="1536192"/>
-            <a:ext cx="11064240" cy="4480560"/>
+            <a:off x="3008376" y="1536192"/>
+            <a:ext cx="6144768" cy="4480560"/>
           </a:xfrm>
           <a:prstGeom prst="rect">
             <a:avLst/>

</xml_diff>